<commit_message>
Improve testbench validation and DQ60 point selection
</commit_message>
<xml_diff>
--- a/01_自吸方案/01_车载系统_10kW_GZS60_v3/06_汇报/CEGR-PEMFC-10kW_Vehicle_Simulink_0608.pptx
+++ b/01_自吸方案/01_车载系统_10kW_GZS60_v3/06_汇报/CEGR-PEMFC-10kW_Vehicle_Simulink_0608.pptx
@@ -5,13 +5,17 @@
     <p:sldMasterId id="2147483648" r:id="rId1"/>
   </p:sldMasterIdLst>
   <p:notesMasterIdLst>
-    <p:notesMasterId r:id="rId6"/>
+    <p:notesMasterId r:id="rId10"/>
   </p:notesMasterIdLst>
   <p:sldIdLst>
     <p:sldId id="377" r:id="rId2"/>
     <p:sldId id="378" r:id="rId3"/>
     <p:sldId id="381" r:id="rId4"/>
     <p:sldId id="382" r:id="rId5"/>
+    <p:sldId id="383" r:id="rId6"/>
+    <p:sldId id="385" r:id="rId7"/>
+    <p:sldId id="387" r:id="rId8"/>
+    <p:sldId id="386" r:id="rId9"/>
   </p:sldIdLst>
   <p:sldSz cx="12192000" cy="6858000"/>
   <p:notesSz cx="6797675" cy="9926638"/>
@@ -245,7 +249,7 @@
             </a:pPr>
             <a:fld id="{F0259903-FC65-400A-9E76-C4C330AD3D6E}" type="datetimeFigureOut">
               <a:rPr lang="zh-CN" altLang="en-US"/>
-              <a:t>2026/6/6</a:t>
+              <a:t>2026/6/7</a:t>
             </a:fld>
             <a:endParaRPr lang="zh-CN" altLang="en-US"/>
           </a:p>
@@ -1478,6 +1482,492 @@
     <p:extLst>
       <p:ext uri="{BB962C8B-B14F-4D97-AF65-F5344CB8AC3E}">
         <p14:creationId xmlns:p14="http://schemas.microsoft.com/office/powerpoint/2010/main" val="1892100798"/>
+      </p:ext>
+    </p:extLst>
+  </p:cSld>
+  <p:clrMapOvr>
+    <a:masterClrMapping/>
+  </p:clrMapOvr>
+</p:notes>
+</file>
+
+<file path=ppt/notesSlides/notesSlide5.xml><?xml version="1.0" encoding="utf-8"?>
+<p:notes xmlns:a="http://schemas.openxmlformats.org/drawingml/2006/main" xmlns:r="http://schemas.openxmlformats.org/officeDocument/2006/relationships" xmlns:p="http://schemas.openxmlformats.org/presentationml/2006/main">
+  <p:cSld>
+    <p:spTree>
+      <p:nvGrpSpPr>
+        <p:cNvPr id="1" name=""/>
+        <p:cNvGrpSpPr/>
+        <p:nvPr/>
+      </p:nvGrpSpPr>
+      <p:grpSpPr>
+        <a:xfrm>
+          <a:off x="0" y="0"/>
+          <a:ext cx="0" cy="0"/>
+          <a:chOff x="0" y="0"/>
+          <a:chExt cx="0" cy="0"/>
+        </a:xfrm>
+      </p:grpSpPr>
+      <p:sp>
+        <p:nvSpPr>
+          <p:cNvPr id="2" name="幻灯片图像占位符 1"/>
+          <p:cNvSpPr>
+            <a:spLocks noGrp="1" noRot="1" noChangeAspect="1"/>
+          </p:cNvSpPr>
+          <p:nvPr>
+            <p:ph type="sldImg"/>
+          </p:nvPr>
+        </p:nvSpPr>
+        <p:spPr/>
+      </p:sp>
+      <p:sp>
+        <p:nvSpPr>
+          <p:cNvPr id="3" name="备注占位符 2"/>
+          <p:cNvSpPr>
+            <a:spLocks noGrp="1"/>
+          </p:cNvSpPr>
+          <p:nvPr>
+            <p:ph type="body" idx="1"/>
+          </p:nvPr>
+        </p:nvSpPr>
+        <p:spPr/>
+        <p:txBody>
+          <a:bodyPr/>
+          <a:lstStyle/>
+          <a:p>
+            <a:endParaRPr lang="zh-CN" altLang="en-US" dirty="0"/>
+          </a:p>
+        </p:txBody>
+      </p:sp>
+      <p:sp>
+        <p:nvSpPr>
+          <p:cNvPr id="4" name="灯片编号占位符 3"/>
+          <p:cNvSpPr>
+            <a:spLocks noGrp="1"/>
+          </p:cNvSpPr>
+          <p:nvPr>
+            <p:ph type="sldNum" sz="quarter" idx="5"/>
+          </p:nvPr>
+        </p:nvSpPr>
+        <p:spPr/>
+        <p:txBody>
+          <a:bodyPr/>
+          <a:lstStyle/>
+          <a:p>
+            <a:pPr>
+              <a:defRPr/>
+            </a:pPr>
+            <a:fld id="{A67DAE94-9449-4026-AC54-378A5A1A8636}" type="slidenum">
+              <a:rPr lang="zh-CN" altLang="en-US" smtClean="0"/>
+              <a:t>5</a:t>
+            </a:fld>
+            <a:endParaRPr lang="zh-CN" altLang="en-US"/>
+          </a:p>
+        </p:txBody>
+      </p:sp>
+    </p:spTree>
+    <p:extLst>
+      <p:ext uri="{BB962C8B-B14F-4D97-AF65-F5344CB8AC3E}">
+        <p14:creationId xmlns:p14="http://schemas.microsoft.com/office/powerpoint/2010/main" val="902636072"/>
+      </p:ext>
+    </p:extLst>
+  </p:cSld>
+  <p:clrMapOvr>
+    <a:masterClrMapping/>
+  </p:clrMapOvr>
+</p:notes>
+</file>
+
+<file path=ppt/notesSlides/notesSlide6.xml><?xml version="1.0" encoding="utf-8"?>
+<p:notes xmlns:a="http://schemas.openxmlformats.org/drawingml/2006/main" xmlns:r="http://schemas.openxmlformats.org/officeDocument/2006/relationships" xmlns:p="http://schemas.openxmlformats.org/presentationml/2006/main">
+  <p:cSld>
+    <p:spTree>
+      <p:nvGrpSpPr>
+        <p:cNvPr id="1" name="">
+          <a:extLst>
+            <a:ext uri="{FF2B5EF4-FFF2-40B4-BE49-F238E27FC236}">
+              <a16:creationId xmlns:a16="http://schemas.microsoft.com/office/drawing/2014/main" id="{00C7C5DB-5F8E-064E-C5EB-B532970F9BAB}"/>
+            </a:ext>
+          </a:extLst>
+        </p:cNvPr>
+        <p:cNvGrpSpPr/>
+        <p:nvPr/>
+      </p:nvGrpSpPr>
+      <p:grpSpPr>
+        <a:xfrm>
+          <a:off x="0" y="0"/>
+          <a:ext cx="0" cy="0"/>
+          <a:chOff x="0" y="0"/>
+          <a:chExt cx="0" cy="0"/>
+        </a:xfrm>
+      </p:grpSpPr>
+      <p:sp>
+        <p:nvSpPr>
+          <p:cNvPr id="2" name="幻灯片图像占位符 1">
+            <a:extLst>
+              <a:ext uri="{FF2B5EF4-FFF2-40B4-BE49-F238E27FC236}">
+                <a16:creationId xmlns:a16="http://schemas.microsoft.com/office/drawing/2014/main" id="{B73D3AD2-A3AA-CF79-6568-B3E9756C4ED0}"/>
+              </a:ext>
+            </a:extLst>
+          </p:cNvPr>
+          <p:cNvSpPr>
+            <a:spLocks noGrp="1" noRot="1" noChangeAspect="1"/>
+          </p:cNvSpPr>
+          <p:nvPr>
+            <p:ph type="sldImg"/>
+          </p:nvPr>
+        </p:nvSpPr>
+        <p:spPr/>
+      </p:sp>
+      <p:sp>
+        <p:nvSpPr>
+          <p:cNvPr id="3" name="备注占位符 2">
+            <a:extLst>
+              <a:ext uri="{FF2B5EF4-FFF2-40B4-BE49-F238E27FC236}">
+                <a16:creationId xmlns:a16="http://schemas.microsoft.com/office/drawing/2014/main" id="{A8AEC828-61E2-3D5A-9CF8-12443717841B}"/>
+              </a:ext>
+            </a:extLst>
+          </p:cNvPr>
+          <p:cNvSpPr>
+            <a:spLocks noGrp="1"/>
+          </p:cNvSpPr>
+          <p:nvPr>
+            <p:ph type="body" idx="1"/>
+          </p:nvPr>
+        </p:nvSpPr>
+        <p:spPr/>
+        <p:txBody>
+          <a:bodyPr/>
+          <a:lstStyle/>
+          <a:p>
+            <a:endParaRPr lang="zh-CN" altLang="en-US" sz="1400" dirty="0">
+              <a:latin typeface="Arial" panose="020B0604020202020204" pitchFamily="34" charset="0"/>
+              <a:ea typeface="微软雅黑" panose="020B0503020204020204" pitchFamily="34" charset="-122"/>
+            </a:endParaRPr>
+          </a:p>
+        </p:txBody>
+      </p:sp>
+      <p:sp>
+        <p:nvSpPr>
+          <p:cNvPr id="4" name="灯片编号占位符 3">
+            <a:extLst>
+              <a:ext uri="{FF2B5EF4-FFF2-40B4-BE49-F238E27FC236}">
+                <a16:creationId xmlns:a16="http://schemas.microsoft.com/office/drawing/2014/main" id="{CAB1CDF8-3133-E8B3-52E7-E16202226C6B}"/>
+              </a:ext>
+            </a:extLst>
+          </p:cNvPr>
+          <p:cNvSpPr>
+            <a:spLocks noGrp="1"/>
+          </p:cNvSpPr>
+          <p:nvPr>
+            <p:ph type="sldNum" sz="quarter" idx="5"/>
+          </p:nvPr>
+        </p:nvSpPr>
+        <p:spPr/>
+        <p:txBody>
+          <a:bodyPr/>
+          <a:lstStyle/>
+          <a:p>
+            <a:pPr>
+              <a:defRPr/>
+            </a:pPr>
+            <a:fld id="{A67DAE94-9449-4026-AC54-378A5A1A8636}" type="slidenum">
+              <a:rPr lang="zh-CN" altLang="en-US" smtClean="0"/>
+              <a:t>6</a:t>
+            </a:fld>
+            <a:endParaRPr lang="zh-CN" altLang="en-US"/>
+          </a:p>
+        </p:txBody>
+      </p:sp>
+    </p:spTree>
+    <p:extLst>
+      <p:ext uri="{BB962C8B-B14F-4D97-AF65-F5344CB8AC3E}">
+        <p14:creationId xmlns:p14="http://schemas.microsoft.com/office/powerpoint/2010/main" val="1617605127"/>
+      </p:ext>
+    </p:extLst>
+  </p:cSld>
+  <p:clrMapOvr>
+    <a:masterClrMapping/>
+  </p:clrMapOvr>
+</p:notes>
+</file>
+
+<file path=ppt/notesSlides/notesSlide7.xml><?xml version="1.0" encoding="utf-8"?>
+<p:notes xmlns:a="http://schemas.openxmlformats.org/drawingml/2006/main" xmlns:r="http://schemas.openxmlformats.org/officeDocument/2006/relationships" xmlns:p="http://schemas.openxmlformats.org/presentationml/2006/main">
+  <p:cSld>
+    <p:spTree>
+      <p:nvGrpSpPr>
+        <p:cNvPr id="1" name="">
+          <a:extLst>
+            <a:ext uri="{FF2B5EF4-FFF2-40B4-BE49-F238E27FC236}">
+              <a16:creationId xmlns:a16="http://schemas.microsoft.com/office/drawing/2014/main" id="{21FBB669-481B-7735-DF0A-69725ECBFFBA}"/>
+            </a:ext>
+          </a:extLst>
+        </p:cNvPr>
+        <p:cNvGrpSpPr/>
+        <p:nvPr/>
+      </p:nvGrpSpPr>
+      <p:grpSpPr>
+        <a:xfrm>
+          <a:off x="0" y="0"/>
+          <a:ext cx="0" cy="0"/>
+          <a:chOff x="0" y="0"/>
+          <a:chExt cx="0" cy="0"/>
+        </a:xfrm>
+      </p:grpSpPr>
+      <p:sp>
+        <p:nvSpPr>
+          <p:cNvPr id="2" name="幻灯片图像占位符 1">
+            <a:extLst>
+              <a:ext uri="{FF2B5EF4-FFF2-40B4-BE49-F238E27FC236}">
+                <a16:creationId xmlns:a16="http://schemas.microsoft.com/office/drawing/2014/main" id="{98A8D9F5-77D1-9293-D864-4237971735A7}"/>
+              </a:ext>
+            </a:extLst>
+          </p:cNvPr>
+          <p:cNvSpPr>
+            <a:spLocks noGrp="1" noRot="1" noChangeAspect="1"/>
+          </p:cNvSpPr>
+          <p:nvPr>
+            <p:ph type="sldImg"/>
+          </p:nvPr>
+        </p:nvSpPr>
+        <p:spPr/>
+      </p:sp>
+      <p:sp>
+        <p:nvSpPr>
+          <p:cNvPr id="3" name="备注占位符 2">
+            <a:extLst>
+              <a:ext uri="{FF2B5EF4-FFF2-40B4-BE49-F238E27FC236}">
+                <a16:creationId xmlns:a16="http://schemas.microsoft.com/office/drawing/2014/main" id="{AFA1DAE9-D2EE-5317-25C7-931331921BA0}"/>
+              </a:ext>
+            </a:extLst>
+          </p:cNvPr>
+          <p:cNvSpPr>
+            <a:spLocks noGrp="1"/>
+          </p:cNvSpPr>
+          <p:nvPr>
+            <p:ph type="body" idx="1"/>
+          </p:nvPr>
+        </p:nvSpPr>
+        <p:spPr/>
+        <p:txBody>
+          <a:bodyPr/>
+          <a:lstStyle/>
+          <a:p>
+            <a:endParaRPr lang="zh-CN" altLang="en-US" dirty="0"/>
+          </a:p>
+        </p:txBody>
+      </p:sp>
+      <p:sp>
+        <p:nvSpPr>
+          <p:cNvPr id="4" name="灯片编号占位符 3">
+            <a:extLst>
+              <a:ext uri="{FF2B5EF4-FFF2-40B4-BE49-F238E27FC236}">
+                <a16:creationId xmlns:a16="http://schemas.microsoft.com/office/drawing/2014/main" id="{BBFA383F-A09B-5A2B-A67D-BCBE830AF05D}"/>
+              </a:ext>
+            </a:extLst>
+          </p:cNvPr>
+          <p:cNvSpPr>
+            <a:spLocks noGrp="1"/>
+          </p:cNvSpPr>
+          <p:nvPr>
+            <p:ph type="sldNum" sz="quarter" idx="5"/>
+          </p:nvPr>
+        </p:nvSpPr>
+        <p:spPr/>
+        <p:txBody>
+          <a:bodyPr/>
+          <a:lstStyle/>
+          <a:p>
+            <a:pPr>
+              <a:defRPr/>
+            </a:pPr>
+            <a:fld id="{A67DAE94-9449-4026-AC54-378A5A1A8636}" type="slidenum">
+              <a:rPr lang="zh-CN" altLang="en-US" smtClean="0"/>
+              <a:t>7</a:t>
+            </a:fld>
+            <a:endParaRPr lang="zh-CN" altLang="en-US"/>
+          </a:p>
+        </p:txBody>
+      </p:sp>
+    </p:spTree>
+    <p:extLst>
+      <p:ext uri="{BB962C8B-B14F-4D97-AF65-F5344CB8AC3E}">
+        <p14:creationId xmlns:p14="http://schemas.microsoft.com/office/powerpoint/2010/main" val="708622461"/>
+      </p:ext>
+    </p:extLst>
+  </p:cSld>
+  <p:clrMapOvr>
+    <a:masterClrMapping/>
+  </p:clrMapOvr>
+</p:notes>
+</file>
+
+<file path=ppt/notesSlides/notesSlide8.xml><?xml version="1.0" encoding="utf-8"?>
+<p:notes xmlns:a="http://schemas.openxmlformats.org/drawingml/2006/main" xmlns:r="http://schemas.openxmlformats.org/officeDocument/2006/relationships" xmlns:p="http://schemas.openxmlformats.org/presentationml/2006/main">
+  <p:cSld>
+    <p:spTree>
+      <p:nvGrpSpPr>
+        <p:cNvPr id="1" name="">
+          <a:extLst>
+            <a:ext uri="{FF2B5EF4-FFF2-40B4-BE49-F238E27FC236}">
+              <a16:creationId xmlns:a16="http://schemas.microsoft.com/office/drawing/2014/main" id="{1ACB17B5-5443-027E-9362-05942E5C17E7}"/>
+            </a:ext>
+          </a:extLst>
+        </p:cNvPr>
+        <p:cNvGrpSpPr/>
+        <p:nvPr/>
+      </p:nvGrpSpPr>
+      <p:grpSpPr>
+        <a:xfrm>
+          <a:off x="0" y="0"/>
+          <a:ext cx="0" cy="0"/>
+          <a:chOff x="0" y="0"/>
+          <a:chExt cx="0" cy="0"/>
+        </a:xfrm>
+      </p:grpSpPr>
+      <p:sp>
+        <p:nvSpPr>
+          <p:cNvPr id="2" name="幻灯片图像占位符 1">
+            <a:extLst>
+              <a:ext uri="{FF2B5EF4-FFF2-40B4-BE49-F238E27FC236}">
+                <a16:creationId xmlns:a16="http://schemas.microsoft.com/office/drawing/2014/main" id="{AD5737AF-3461-216F-EAB6-7D6878E818F6}"/>
+              </a:ext>
+            </a:extLst>
+          </p:cNvPr>
+          <p:cNvSpPr>
+            <a:spLocks noGrp="1" noRot="1" noChangeAspect="1"/>
+          </p:cNvSpPr>
+          <p:nvPr>
+            <p:ph type="sldImg"/>
+          </p:nvPr>
+        </p:nvSpPr>
+        <p:spPr/>
+      </p:sp>
+      <p:sp>
+        <p:nvSpPr>
+          <p:cNvPr id="3" name="备注占位符 2">
+            <a:extLst>
+              <a:ext uri="{FF2B5EF4-FFF2-40B4-BE49-F238E27FC236}">
+                <a16:creationId xmlns:a16="http://schemas.microsoft.com/office/drawing/2014/main" id="{81EA3490-E1A1-F24D-3EBD-A1A9A40C861D}"/>
+              </a:ext>
+            </a:extLst>
+          </p:cNvPr>
+          <p:cNvSpPr>
+            <a:spLocks noGrp="1"/>
+          </p:cNvSpPr>
+          <p:nvPr>
+            <p:ph type="body" idx="1"/>
+          </p:nvPr>
+        </p:nvSpPr>
+        <p:spPr/>
+        <p:txBody>
+          <a:bodyPr/>
+          <a:lstStyle/>
+          <a:p>
+            <a:r>
+              <a:rPr lang="en-US" altLang="zh-CN" sz="2000" b="1" i="0" dirty="0">
+                <a:solidFill>
+                  <a:srgbClr val="1A1C1F"/>
+                </a:solidFill>
+                <a:effectLst/>
+                <a:latin typeface="-apple-system"/>
+              </a:rPr>
+              <a:t>EGR </a:t>
+            </a:r>
+            <a:r>
+              <a:rPr lang="zh-CN" altLang="en-US" sz="2000" b="1" i="0" dirty="0">
+                <a:solidFill>
+                  <a:srgbClr val="1A1C1F"/>
+                </a:solidFill>
+                <a:effectLst/>
+                <a:latin typeface="-apple-system"/>
+              </a:rPr>
+              <a:t>稀释后，要把入口氧气压力环境恢复到无 </a:t>
+            </a:r>
+            <a:r>
+              <a:rPr lang="en-US" altLang="zh-CN" sz="2000" b="1" i="0" dirty="0">
+                <a:solidFill>
+                  <a:srgbClr val="1A1C1F"/>
+                </a:solidFill>
+                <a:effectLst/>
+                <a:latin typeface="-apple-system"/>
+              </a:rPr>
+              <a:t>EGR </a:t>
+            </a:r>
+            <a:r>
+              <a:rPr lang="zh-CN" altLang="en-US" sz="2000" b="1" i="0" dirty="0">
+                <a:solidFill>
+                  <a:srgbClr val="1A1C1F"/>
+                </a:solidFill>
+                <a:effectLst/>
+                <a:latin typeface="-apple-system"/>
+              </a:rPr>
+              <a:t>基准，需要空压机</a:t>
+            </a:r>
+            <a:r>
+              <a:rPr lang="en-US" altLang="zh-CN" sz="2000" b="1" i="0" dirty="0">
+                <a:solidFill>
+                  <a:srgbClr val="1A1C1F"/>
+                </a:solidFill>
+                <a:effectLst/>
+                <a:latin typeface="-apple-system"/>
+              </a:rPr>
+              <a:t>/</a:t>
+            </a:r>
+            <a:r>
+              <a:rPr lang="zh-CN" altLang="en-US" sz="2000" b="1" i="0" dirty="0">
+                <a:solidFill>
+                  <a:srgbClr val="1A1C1F"/>
+                </a:solidFill>
+                <a:effectLst/>
+                <a:latin typeface="-apple-system"/>
+              </a:rPr>
+              <a:t>台架供气提高到什么程度；这时氧气实际入堆流量可能会比基准高。</a:t>
+            </a:r>
+            <a:endParaRPr lang="zh-CN" altLang="en-US" sz="1400" dirty="0">
+              <a:latin typeface="Arial" panose="020B0604020202020204" pitchFamily="34" charset="0"/>
+              <a:ea typeface="微软雅黑" panose="020B0503020204020204" pitchFamily="34" charset="-122"/>
+            </a:endParaRPr>
+          </a:p>
+        </p:txBody>
+      </p:sp>
+      <p:sp>
+        <p:nvSpPr>
+          <p:cNvPr id="4" name="灯片编号占位符 3">
+            <a:extLst>
+              <a:ext uri="{FF2B5EF4-FFF2-40B4-BE49-F238E27FC236}">
+                <a16:creationId xmlns:a16="http://schemas.microsoft.com/office/drawing/2014/main" id="{D6997D3D-B299-8321-E12E-4FC4AD01D13B}"/>
+              </a:ext>
+            </a:extLst>
+          </p:cNvPr>
+          <p:cNvSpPr>
+            <a:spLocks noGrp="1"/>
+          </p:cNvSpPr>
+          <p:nvPr>
+            <p:ph type="sldNum" sz="quarter" idx="5"/>
+          </p:nvPr>
+        </p:nvSpPr>
+        <p:spPr/>
+        <p:txBody>
+          <a:bodyPr/>
+          <a:lstStyle/>
+          <a:p>
+            <a:pPr>
+              <a:defRPr/>
+            </a:pPr>
+            <a:fld id="{A67DAE94-9449-4026-AC54-378A5A1A8636}" type="slidenum">
+              <a:rPr lang="zh-CN" altLang="en-US" smtClean="0"/>
+              <a:t>8</a:t>
+            </a:fld>
+            <a:endParaRPr lang="zh-CN" altLang="en-US"/>
+          </a:p>
+        </p:txBody>
+      </p:sp>
+    </p:spTree>
+    <p:extLst>
+      <p:ext uri="{BB962C8B-B14F-4D97-AF65-F5344CB8AC3E}">
+        <p14:creationId xmlns:p14="http://schemas.microsoft.com/office/powerpoint/2010/main" val="4246247350"/>
       </p:ext>
     </p:extLst>
   </p:cSld>
@@ -5892,6 +6382,16 @@
           <a:bodyPr wrap="square"/>
           <a:lstStyle/>
           <a:p>
+            <a:r>
+              <a:rPr lang="zh-CN" altLang="en-US" sz="2400" b="1" dirty="0">
+                <a:solidFill>
+                  <a:schemeClr val="accent1"/>
+                </a:solidFill>
+                <a:latin typeface="Arial" panose="020B0604020202020204" pitchFamily="34" charset="0"/>
+                <a:sym typeface="+mn-ea"/>
+              </a:rPr>
+              <a:t>车载结构</a:t>
+            </a:r>
             <a:r>
               <a:rPr lang="zh-CN" altLang="en-US" sz="2400" dirty="0">
                 <a:solidFill>
@@ -6706,6 +7206,16 @@
           <a:lstStyle/>
           <a:p>
             <a:r>
+              <a:rPr lang="zh-CN" altLang="en-US" sz="2400" b="1" dirty="0">
+                <a:solidFill>
+                  <a:schemeClr val="accent1"/>
+                </a:solidFill>
+                <a:latin typeface="Arial" panose="020B0604020202020204" pitchFamily="34" charset="0"/>
+                <a:sym typeface="+mn-ea"/>
+              </a:rPr>
+              <a:t>车载结构</a:t>
+            </a:r>
+            <a:r>
               <a:rPr lang="zh-CN" altLang="en-US" sz="2400" dirty="0">
                 <a:solidFill>
                   <a:schemeClr val="accent1"/>
@@ -6884,7 +7394,7 @@
         </p:nvSpPr>
         <p:spPr>
           <a:xfrm>
-            <a:off x="2207568" y="1947996"/>
+            <a:off x="2207568" y="1896410"/>
             <a:ext cx="914400" cy="914400"/>
           </a:xfrm>
           <a:prstGeom prst="rect">
@@ -6938,7 +7448,7 @@
         </p:nvSpPr>
         <p:spPr>
           <a:xfrm>
-            <a:off x="5638800" y="1844824"/>
+            <a:off x="5638800" y="1896410"/>
             <a:ext cx="914400" cy="914400"/>
           </a:xfrm>
           <a:prstGeom prst="rect">
@@ -6992,7 +7502,7 @@
         </p:nvSpPr>
         <p:spPr>
           <a:xfrm>
-            <a:off x="9070032" y="1881348"/>
+            <a:off x="9070032" y="1896410"/>
             <a:ext cx="914400" cy="914400"/>
           </a:xfrm>
           <a:prstGeom prst="rect">
@@ -7046,7 +7556,7 @@
         </p:nvSpPr>
         <p:spPr>
           <a:xfrm>
-            <a:off x="2156139" y="4310580"/>
+            <a:off x="2156139" y="4313220"/>
             <a:ext cx="914400" cy="914400"/>
           </a:xfrm>
           <a:prstGeom prst="rect">
@@ -7100,7 +7610,7 @@
         </p:nvSpPr>
         <p:spPr>
           <a:xfrm>
-            <a:off x="5638800" y="4315860"/>
+            <a:off x="5638800" y="4313220"/>
             <a:ext cx="914400" cy="914400"/>
           </a:xfrm>
           <a:prstGeom prst="rect">
@@ -7154,7 +7664,7 @@
         </p:nvSpPr>
         <p:spPr>
           <a:xfrm>
-            <a:off x="9070032" y="4315860"/>
+            <a:off x="9070032" y="4313220"/>
             <a:ext cx="914400" cy="914400"/>
           </a:xfrm>
           <a:prstGeom prst="rect">
@@ -7288,6 +7798,16 @@
           <a:lstStyle/>
           <a:p>
             <a:r>
+              <a:rPr lang="zh-CN" altLang="en-US" sz="2400" b="1" dirty="0">
+                <a:solidFill>
+                  <a:schemeClr val="accent1"/>
+                </a:solidFill>
+                <a:latin typeface="Arial" panose="020B0604020202020204" pitchFamily="34" charset="0"/>
+                <a:sym typeface="+mn-ea"/>
+              </a:rPr>
+              <a:t>车载结构</a:t>
+            </a:r>
+            <a:r>
               <a:rPr lang="zh-CN" altLang="en-US" sz="2400" dirty="0">
                 <a:solidFill>
                   <a:schemeClr val="accent1"/>
@@ -7469,7 +7989,7 @@
         </p:nvSpPr>
         <p:spPr>
           <a:xfrm>
-            <a:off x="2207568" y="1947996"/>
+            <a:off x="2207568" y="1896410"/>
             <a:ext cx="914400" cy="914400"/>
           </a:xfrm>
           <a:prstGeom prst="rect">
@@ -7523,7 +8043,7 @@
         </p:nvSpPr>
         <p:spPr>
           <a:xfrm>
-            <a:off x="5638800" y="1844824"/>
+            <a:off x="5638800" y="1896410"/>
             <a:ext cx="914400" cy="914400"/>
           </a:xfrm>
           <a:prstGeom prst="rect">
@@ -7577,7 +8097,7 @@
         </p:nvSpPr>
         <p:spPr>
           <a:xfrm>
-            <a:off x="9070032" y="1881348"/>
+            <a:off x="9070032" y="1896410"/>
             <a:ext cx="914400" cy="914400"/>
           </a:xfrm>
           <a:prstGeom prst="rect">
@@ -7631,7 +8151,7 @@
         </p:nvSpPr>
         <p:spPr>
           <a:xfrm>
-            <a:off x="2156139" y="4310580"/>
+            <a:off x="2156139" y="4313220"/>
             <a:ext cx="914400" cy="914400"/>
           </a:xfrm>
           <a:prstGeom prst="rect">
@@ -7685,7 +8205,7 @@
         </p:nvSpPr>
         <p:spPr>
           <a:xfrm>
-            <a:off x="5638800" y="4315860"/>
+            <a:off x="5638800" y="4313220"/>
             <a:ext cx="914400" cy="914400"/>
           </a:xfrm>
           <a:prstGeom prst="rect">
@@ -7739,7 +8259,7 @@
         </p:nvSpPr>
         <p:spPr>
           <a:xfrm>
-            <a:off x="9070032" y="4315860"/>
+            <a:off x="9070032" y="4313220"/>
             <a:ext cx="914400" cy="914400"/>
           </a:xfrm>
           <a:prstGeom prst="rect">
@@ -7873,6 +8393,16 @@
           <a:lstStyle/>
           <a:p>
             <a:r>
+              <a:rPr lang="zh-CN" altLang="en-US" sz="2400" b="1" dirty="0">
+                <a:solidFill>
+                  <a:schemeClr val="accent1"/>
+                </a:solidFill>
+                <a:latin typeface="Arial" panose="020B0604020202020204" pitchFamily="34" charset="0"/>
+                <a:sym typeface="+mn-ea"/>
+              </a:rPr>
+              <a:t>车载结构</a:t>
+            </a:r>
+            <a:r>
               <a:rPr lang="zh-CN" altLang="en-US" sz="2400" dirty="0">
                 <a:solidFill>
                   <a:schemeClr val="accent1"/>
@@ -8051,6 +8581,2336 @@
         </p:nvSpPr>
         <p:spPr>
           <a:xfrm>
+            <a:off x="2207568" y="1896410"/>
+            <a:ext cx="914400" cy="914400"/>
+          </a:xfrm>
+          <a:prstGeom prst="rect">
+            <a:avLst/>
+          </a:prstGeom>
+          <a:noFill/>
+        </p:spPr>
+        <p:txBody>
+          <a:bodyPr wrap="none" lIns="36000" tIns="36000" rIns="36000" bIns="36000" rtlCol="0">
+            <a:noAutofit/>
+          </a:bodyPr>
+          <a:lstStyle/>
+          <a:p>
+            <a:pPr algn="ctr">
+              <a:spcBef>
+                <a:spcPts val="600"/>
+              </a:spcBef>
+            </a:pPr>
+            <a:r>
+              <a:rPr lang="en-US" altLang="zh-CN" sz="1400" dirty="0">
+                <a:solidFill>
+                  <a:schemeClr val="accent4"/>
+                </a:solidFill>
+                <a:latin typeface="+mj-lt"/>
+              </a:rPr>
+              <a:t>1.</a:t>
+            </a:r>
+            <a:r>
+              <a:rPr lang="zh-CN" altLang="en-US" sz="1400" dirty="0">
+                <a:solidFill>
+                  <a:schemeClr val="accent4"/>
+                </a:solidFill>
+                <a:latin typeface="+mj-lt"/>
+              </a:rPr>
+              <a:t>电压</a:t>
+            </a:r>
+          </a:p>
+        </p:txBody>
+      </p:sp>
+      <p:sp>
+        <p:nvSpPr>
+          <p:cNvPr id="5" name="文本框 4">
+            <a:extLst>
+              <a:ext uri="{FF2B5EF4-FFF2-40B4-BE49-F238E27FC236}">
+                <a16:creationId xmlns:a16="http://schemas.microsoft.com/office/drawing/2014/main" id="{B5260BA2-6F83-E971-ED75-4F083A21F2EA}"/>
+              </a:ext>
+            </a:extLst>
+          </p:cNvPr>
+          <p:cNvSpPr txBox="1"/>
+          <p:nvPr/>
+        </p:nvSpPr>
+        <p:spPr>
+          <a:xfrm>
+            <a:off x="5638800" y="1896410"/>
+            <a:ext cx="914400" cy="914400"/>
+          </a:xfrm>
+          <a:prstGeom prst="rect">
+            <a:avLst/>
+          </a:prstGeom>
+          <a:noFill/>
+        </p:spPr>
+        <p:txBody>
+          <a:bodyPr wrap="none" lIns="36000" tIns="36000" rIns="36000" bIns="36000" rtlCol="0">
+            <a:noAutofit/>
+          </a:bodyPr>
+          <a:lstStyle/>
+          <a:p>
+            <a:pPr algn="ctr">
+              <a:spcBef>
+                <a:spcPts val="600"/>
+              </a:spcBef>
+            </a:pPr>
+            <a:r>
+              <a:rPr lang="en-US" altLang="zh-CN" sz="1400" dirty="0">
+                <a:solidFill>
+                  <a:schemeClr val="accent4"/>
+                </a:solidFill>
+                <a:latin typeface="+mj-lt"/>
+              </a:rPr>
+              <a:t>2.</a:t>
+            </a:r>
+            <a:r>
+              <a:rPr lang="zh-CN" altLang="en-US" sz="1400" dirty="0">
+                <a:solidFill>
+                  <a:schemeClr val="accent4"/>
+                </a:solidFill>
+                <a:latin typeface="+mj-lt"/>
+              </a:rPr>
+              <a:t>阴极入口氧分压</a:t>
+            </a:r>
+          </a:p>
+        </p:txBody>
+      </p:sp>
+      <p:sp>
+        <p:nvSpPr>
+          <p:cNvPr id="6" name="文本框 5">
+            <a:extLst>
+              <a:ext uri="{FF2B5EF4-FFF2-40B4-BE49-F238E27FC236}">
+                <a16:creationId xmlns:a16="http://schemas.microsoft.com/office/drawing/2014/main" id="{667208A5-C5B5-2A88-463F-5EDE9B1401D5}"/>
+              </a:ext>
+            </a:extLst>
+          </p:cNvPr>
+          <p:cNvSpPr txBox="1"/>
+          <p:nvPr/>
+        </p:nvSpPr>
+        <p:spPr>
+          <a:xfrm>
+            <a:off x="9070032" y="1896410"/>
+            <a:ext cx="914400" cy="914400"/>
+          </a:xfrm>
+          <a:prstGeom prst="rect">
+            <a:avLst/>
+          </a:prstGeom>
+          <a:noFill/>
+        </p:spPr>
+        <p:txBody>
+          <a:bodyPr wrap="none" lIns="36000" tIns="36000" rIns="36000" bIns="36000" rtlCol="0">
+            <a:noAutofit/>
+          </a:bodyPr>
+          <a:lstStyle/>
+          <a:p>
+            <a:pPr algn="ctr">
+              <a:spcBef>
+                <a:spcPts val="600"/>
+              </a:spcBef>
+            </a:pPr>
+            <a:r>
+              <a:rPr lang="en-US" altLang="zh-CN" sz="1400" dirty="0">
+                <a:solidFill>
+                  <a:schemeClr val="accent4"/>
+                </a:solidFill>
+                <a:latin typeface="+mj-lt"/>
+              </a:rPr>
+              <a:t>3.</a:t>
+            </a:r>
+            <a:r>
+              <a:rPr lang="zh-CN" altLang="en-US" sz="1400" dirty="0">
+                <a:solidFill>
+                  <a:schemeClr val="accent4"/>
+                </a:solidFill>
+                <a:latin typeface="+mj-lt"/>
+              </a:rPr>
+              <a:t>氧计量比</a:t>
+            </a:r>
+          </a:p>
+        </p:txBody>
+      </p:sp>
+      <p:sp>
+        <p:nvSpPr>
+          <p:cNvPr id="7" name="文本框 6">
+            <a:extLst>
+              <a:ext uri="{FF2B5EF4-FFF2-40B4-BE49-F238E27FC236}">
+                <a16:creationId xmlns:a16="http://schemas.microsoft.com/office/drawing/2014/main" id="{E1A6F071-81AF-A59A-1FAD-CF3C6F69FF4B}"/>
+              </a:ext>
+            </a:extLst>
+          </p:cNvPr>
+          <p:cNvSpPr txBox="1"/>
+          <p:nvPr/>
+        </p:nvSpPr>
+        <p:spPr>
+          <a:xfrm>
+            <a:off x="2156139" y="4313220"/>
+            <a:ext cx="914400" cy="914400"/>
+          </a:xfrm>
+          <a:prstGeom prst="rect">
+            <a:avLst/>
+          </a:prstGeom>
+          <a:noFill/>
+        </p:spPr>
+        <p:txBody>
+          <a:bodyPr wrap="none" lIns="36000" tIns="36000" rIns="36000" bIns="36000" rtlCol="0">
+            <a:noAutofit/>
+          </a:bodyPr>
+          <a:lstStyle/>
+          <a:p>
+            <a:pPr algn="ctr">
+              <a:spcBef>
+                <a:spcPts val="600"/>
+              </a:spcBef>
+            </a:pPr>
+            <a:r>
+              <a:rPr lang="en-US" altLang="zh-CN" sz="1400" dirty="0">
+                <a:solidFill>
+                  <a:schemeClr val="accent4"/>
+                </a:solidFill>
+                <a:latin typeface="+mj-lt"/>
+              </a:rPr>
+              <a:t>4.</a:t>
+            </a:r>
+            <a:r>
+              <a:rPr lang="zh-CN" altLang="en-US" sz="1400" dirty="0">
+                <a:solidFill>
+                  <a:schemeClr val="accent4"/>
+                </a:solidFill>
+                <a:latin typeface="+mj-lt"/>
+              </a:rPr>
+              <a:t>空压机流量</a:t>
+            </a:r>
+          </a:p>
+        </p:txBody>
+      </p:sp>
+      <p:sp>
+        <p:nvSpPr>
+          <p:cNvPr id="8" name="文本框 7">
+            <a:extLst>
+              <a:ext uri="{FF2B5EF4-FFF2-40B4-BE49-F238E27FC236}">
+                <a16:creationId xmlns:a16="http://schemas.microsoft.com/office/drawing/2014/main" id="{9EAF24CA-7E6B-A510-956F-238C2B2C2A7C}"/>
+              </a:ext>
+            </a:extLst>
+          </p:cNvPr>
+          <p:cNvSpPr txBox="1"/>
+          <p:nvPr/>
+        </p:nvSpPr>
+        <p:spPr>
+          <a:xfrm>
+            <a:off x="5638800" y="4313220"/>
+            <a:ext cx="914400" cy="914400"/>
+          </a:xfrm>
+          <a:prstGeom prst="rect">
+            <a:avLst/>
+          </a:prstGeom>
+          <a:noFill/>
+        </p:spPr>
+        <p:txBody>
+          <a:bodyPr wrap="none" lIns="36000" tIns="36000" rIns="36000" bIns="36000" rtlCol="0">
+            <a:noAutofit/>
+          </a:bodyPr>
+          <a:lstStyle/>
+          <a:p>
+            <a:pPr algn="ctr">
+              <a:spcBef>
+                <a:spcPts val="600"/>
+              </a:spcBef>
+            </a:pPr>
+            <a:r>
+              <a:rPr lang="en-US" altLang="zh-CN" sz="1400" dirty="0">
+                <a:solidFill>
+                  <a:schemeClr val="accent4"/>
+                </a:solidFill>
+                <a:latin typeface="+mj-lt"/>
+              </a:rPr>
+              <a:t>5.</a:t>
+            </a:r>
+            <a:r>
+              <a:rPr lang="zh-CN" altLang="en-US" sz="1400" dirty="0">
+                <a:solidFill>
+                  <a:schemeClr val="accent4"/>
+                </a:solidFill>
+                <a:latin typeface="+mj-lt"/>
+              </a:rPr>
+              <a:t>阴极入口水蒸气分压</a:t>
+            </a:r>
+          </a:p>
+        </p:txBody>
+      </p:sp>
+      <p:sp>
+        <p:nvSpPr>
+          <p:cNvPr id="9" name="文本框 8">
+            <a:extLst>
+              <a:ext uri="{FF2B5EF4-FFF2-40B4-BE49-F238E27FC236}">
+                <a16:creationId xmlns:a16="http://schemas.microsoft.com/office/drawing/2014/main" id="{BA1994F6-AE87-3172-23C9-A8309291CDA9}"/>
+              </a:ext>
+            </a:extLst>
+          </p:cNvPr>
+          <p:cNvSpPr txBox="1"/>
+          <p:nvPr/>
+        </p:nvSpPr>
+        <p:spPr>
+          <a:xfrm>
+            <a:off x="9070032" y="4313220"/>
+            <a:ext cx="914400" cy="914400"/>
+          </a:xfrm>
+          <a:prstGeom prst="rect">
+            <a:avLst/>
+          </a:prstGeom>
+          <a:noFill/>
+        </p:spPr>
+        <p:txBody>
+          <a:bodyPr wrap="none" lIns="36000" tIns="36000" rIns="36000" bIns="36000" rtlCol="0">
+            <a:noAutofit/>
+          </a:bodyPr>
+          <a:lstStyle/>
+          <a:p>
+            <a:pPr algn="ctr">
+              <a:spcBef>
+                <a:spcPts val="600"/>
+              </a:spcBef>
+            </a:pPr>
+            <a:r>
+              <a:rPr lang="en-US" altLang="zh-CN" sz="1400" dirty="0">
+                <a:solidFill>
+                  <a:schemeClr val="accent4"/>
+                </a:solidFill>
+                <a:latin typeface="+mj-lt"/>
+              </a:rPr>
+              <a:t>6.</a:t>
+            </a:r>
+            <a:r>
+              <a:rPr lang="zh-CN" altLang="en-US" sz="1400" dirty="0">
+                <a:solidFill>
+                  <a:schemeClr val="accent4"/>
+                </a:solidFill>
+                <a:latin typeface="+mj-lt"/>
+              </a:rPr>
+              <a:t>温度</a:t>
+            </a:r>
+          </a:p>
+        </p:txBody>
+      </p:sp>
+    </p:spTree>
+    <p:extLst>
+      <p:ext uri="{BB962C8B-B14F-4D97-AF65-F5344CB8AC3E}">
+        <p14:creationId xmlns:p14="http://schemas.microsoft.com/office/powerpoint/2010/main" val="914471329"/>
+      </p:ext>
+    </p:extLst>
+  </p:cSld>
+  <p:clrMapOvr>
+    <a:masterClrMapping/>
+  </p:clrMapOvr>
+</p:sld>
+</file>
+
+<file path=ppt/slides/slide5.xml><?xml version="1.0" encoding="utf-8"?>
+<p:sld xmlns:a="http://schemas.openxmlformats.org/drawingml/2006/main" xmlns:r="http://schemas.openxmlformats.org/officeDocument/2006/relationships" xmlns:p="http://schemas.openxmlformats.org/presentationml/2006/main">
+  <p:cSld>
+    <p:spTree>
+      <p:nvGrpSpPr>
+        <p:cNvPr id="1" name=""/>
+        <p:cNvGrpSpPr/>
+        <p:nvPr/>
+      </p:nvGrpSpPr>
+      <p:grpSpPr>
+        <a:xfrm>
+          <a:off x="0" y="0"/>
+          <a:ext cx="0" cy="0"/>
+          <a:chOff x="0" y="0"/>
+          <a:chExt cx="0" cy="0"/>
+        </a:xfrm>
+      </p:grpSpPr>
+      <p:pic>
+        <p:nvPicPr>
+          <p:cNvPr id="21" name="图片 20">
+            <a:extLst>
+              <a:ext uri="{FF2B5EF4-FFF2-40B4-BE49-F238E27FC236}">
+                <a16:creationId xmlns:a16="http://schemas.microsoft.com/office/drawing/2014/main" id="{CB549841-9C3F-8C82-6099-19A9B9BC56B1}"/>
+              </a:ext>
+            </a:extLst>
+          </p:cNvPr>
+          <p:cNvPicPr>
+            <a:picLocks/>
+          </p:cNvPicPr>
+          <p:nvPr/>
+        </p:nvPicPr>
+        <p:blipFill>
+          <a:blip r:embed="rId3" cstate="print">
+            <a:extLst>
+              <a:ext uri="{28A0092B-C50C-407E-A947-70E740481C1C}">
+                <a14:useLocalDpi xmlns:a14="http://schemas.microsoft.com/office/drawing/2010/main" val="0"/>
+              </a:ext>
+            </a:extLst>
+          </a:blip>
+          <a:srcRect t="6980"/>
+          <a:stretch/>
+        </p:blipFill>
+        <p:spPr>
+          <a:xfrm>
+            <a:off x="5591944" y="941652"/>
+            <a:ext cx="5466480" cy="2638801"/>
+          </a:xfrm>
+          <a:prstGeom prst="rect">
+            <a:avLst/>
+          </a:prstGeom>
+        </p:spPr>
+      </p:pic>
+      <p:pic>
+        <p:nvPicPr>
+          <p:cNvPr id="19" name="图片 18">
+            <a:extLst>
+              <a:ext uri="{FF2B5EF4-FFF2-40B4-BE49-F238E27FC236}">
+                <a16:creationId xmlns:a16="http://schemas.microsoft.com/office/drawing/2014/main" id="{E600BD76-15F7-4A68-60A2-3EEBBCED4E81}"/>
+              </a:ext>
+            </a:extLst>
+          </p:cNvPr>
+          <p:cNvPicPr>
+            <a:picLocks noChangeAspect="1"/>
+          </p:cNvPicPr>
+          <p:nvPr/>
+        </p:nvPicPr>
+        <p:blipFill>
+          <a:blip r:embed="rId4" cstate="print">
+            <a:extLst>
+              <a:ext uri="{28A0092B-C50C-407E-A947-70E740481C1C}">
+                <a14:useLocalDpi xmlns:a14="http://schemas.microsoft.com/office/drawing/2010/main" val="0"/>
+              </a:ext>
+            </a:extLst>
+          </a:blip>
+          <a:stretch>
+            <a:fillRect/>
+          </a:stretch>
+        </p:blipFill>
+        <p:spPr>
+          <a:xfrm>
+            <a:off x="5479177" y="3904184"/>
+            <a:ext cx="5551143" cy="2638800"/>
+          </a:xfrm>
+          <a:prstGeom prst="rect">
+            <a:avLst/>
+          </a:prstGeom>
+        </p:spPr>
+      </p:pic>
+      <p:sp>
+        <p:nvSpPr>
+          <p:cNvPr id="2" name="文本占位符 1">
+            <a:extLst>
+              <a:ext uri="{FF2B5EF4-FFF2-40B4-BE49-F238E27FC236}">
+                <a16:creationId xmlns:a16="http://schemas.microsoft.com/office/drawing/2014/main" id="{B0A88101-31BA-96D3-F721-DA9B4A5D5026}"/>
+              </a:ext>
+            </a:extLst>
+          </p:cNvPr>
+          <p:cNvSpPr>
+            <a:spLocks noGrp="1"/>
+          </p:cNvSpPr>
+          <p:nvPr>
+            <p:ph type="body" sz="quarter" idx="12"/>
+          </p:nvPr>
+        </p:nvSpPr>
+        <p:spPr/>
+        <p:txBody>
+          <a:bodyPr/>
+          <a:lstStyle/>
+          <a:p>
+            <a:r>
+              <a:rPr lang="zh-CN" altLang="en-US" sz="2400" dirty="0">
+                <a:solidFill>
+                  <a:schemeClr val="accent1"/>
+                </a:solidFill>
+                <a:latin typeface="Arial" panose="020B0604020202020204" pitchFamily="34" charset="0"/>
+                <a:sym typeface="+mn-ea"/>
+              </a:rPr>
+              <a:t>台架结构模型内容</a:t>
+            </a:r>
+          </a:p>
+        </p:txBody>
+      </p:sp>
+      <p:pic>
+        <p:nvPicPr>
+          <p:cNvPr id="5" name="图片 4">
+            <a:extLst>
+              <a:ext uri="{FF2B5EF4-FFF2-40B4-BE49-F238E27FC236}">
+                <a16:creationId xmlns:a16="http://schemas.microsoft.com/office/drawing/2014/main" id="{55234A76-4EC8-687C-B117-809D7D9601DD}"/>
+              </a:ext>
+            </a:extLst>
+          </p:cNvPr>
+          <p:cNvPicPr>
+            <a:picLocks noChangeAspect="1"/>
+          </p:cNvPicPr>
+          <p:nvPr/>
+        </p:nvPicPr>
+        <p:blipFill>
+          <a:blip r:embed="rId5">
+            <a:extLst>
+              <a:ext uri="{28A0092B-C50C-407E-A947-70E740481C1C}">
+                <a14:useLocalDpi xmlns:a14="http://schemas.microsoft.com/office/drawing/2010/main" val="0"/>
+              </a:ext>
+            </a:extLst>
+          </a:blip>
+          <a:stretch>
+            <a:fillRect/>
+          </a:stretch>
+        </p:blipFill>
+        <p:spPr>
+          <a:xfrm>
+            <a:off x="1126476" y="1847038"/>
+            <a:ext cx="3188233" cy="2389082"/>
+          </a:xfrm>
+          <a:prstGeom prst="rect">
+            <a:avLst/>
+          </a:prstGeom>
+        </p:spPr>
+      </p:pic>
+      <p:sp>
+        <p:nvSpPr>
+          <p:cNvPr id="6" name="文本框 5">
+            <a:extLst>
+              <a:ext uri="{FF2B5EF4-FFF2-40B4-BE49-F238E27FC236}">
+                <a16:creationId xmlns:a16="http://schemas.microsoft.com/office/drawing/2014/main" id="{14799799-07C5-86A6-A0B9-D64617E002FE}"/>
+              </a:ext>
+            </a:extLst>
+          </p:cNvPr>
+          <p:cNvSpPr txBox="1"/>
+          <p:nvPr/>
+        </p:nvSpPr>
+        <p:spPr>
+          <a:xfrm>
+            <a:off x="908799" y="4480553"/>
+            <a:ext cx="3600400" cy="1224136"/>
+          </a:xfrm>
+          <a:prstGeom prst="rect">
+            <a:avLst/>
+          </a:prstGeom>
+          <a:noFill/>
+        </p:spPr>
+        <p:txBody>
+          <a:bodyPr wrap="square" lIns="36000" tIns="36000" rIns="36000" bIns="36000" rtlCol="0">
+            <a:noAutofit/>
+          </a:bodyPr>
+          <a:lstStyle/>
+          <a:p>
+            <a:pPr algn="l">
+              <a:lnSpc>
+                <a:spcPct val="150000"/>
+              </a:lnSpc>
+              <a:spcBef>
+                <a:spcPts val="600"/>
+              </a:spcBef>
+            </a:pPr>
+            <a:r>
+              <a:rPr lang="zh-CN" altLang="en-US" sz="1400" dirty="0">
+                <a:solidFill>
+                  <a:srgbClr val="152A8C"/>
+                </a:solidFill>
+                <a:sym typeface="+mn-ea"/>
+              </a:rPr>
+              <a:t>模型采用自吸方式台架测试，参数基于短堆台架测试数据、</a:t>
+            </a:r>
+            <a:r>
+              <a:rPr lang="en-US" altLang="zh-CN" sz="1400" dirty="0">
+                <a:solidFill>
+                  <a:srgbClr val="152A8C"/>
+                </a:solidFill>
+                <a:sym typeface="+mn-ea"/>
+              </a:rPr>
+              <a:t>60DQ</a:t>
+            </a:r>
+            <a:r>
+              <a:rPr lang="zh-CN" altLang="en-US" sz="1400" dirty="0">
+                <a:solidFill>
+                  <a:srgbClr val="152A8C"/>
+                </a:solidFill>
+                <a:sym typeface="+mn-ea"/>
+              </a:rPr>
+              <a:t>氢气循环泵拟合，用于</a:t>
+            </a:r>
+            <a:r>
+              <a:rPr lang="en-US" altLang="zh-CN" sz="1400" dirty="0">
+                <a:solidFill>
+                  <a:srgbClr val="152A8C"/>
+                </a:solidFill>
+                <a:sym typeface="+mn-ea"/>
+              </a:rPr>
+              <a:t>EGR</a:t>
+            </a:r>
+            <a:r>
+              <a:rPr lang="zh-CN" altLang="en-US" sz="1400" dirty="0">
+                <a:solidFill>
+                  <a:srgbClr val="152A8C"/>
+                </a:solidFill>
+                <a:sym typeface="+mn-ea"/>
+              </a:rPr>
+              <a:t>工况趋势判断。</a:t>
+            </a:r>
+            <a:endParaRPr lang="zh-CN" altLang="en-US" sz="1400" dirty="0">
+              <a:solidFill>
+                <a:srgbClr val="152A8C"/>
+              </a:solidFill>
+            </a:endParaRPr>
+          </a:p>
+        </p:txBody>
+      </p:sp>
+      <p:sp>
+        <p:nvSpPr>
+          <p:cNvPr id="9" name="文本框 8">
+            <a:extLst>
+              <a:ext uri="{FF2B5EF4-FFF2-40B4-BE49-F238E27FC236}">
+                <a16:creationId xmlns:a16="http://schemas.microsoft.com/office/drawing/2014/main" id="{8E8A93D3-5762-7941-B699-74EC6DCA9390}"/>
+              </a:ext>
+            </a:extLst>
+          </p:cNvPr>
+          <p:cNvSpPr txBox="1"/>
+          <p:nvPr/>
+        </p:nvSpPr>
+        <p:spPr>
+          <a:xfrm>
+            <a:off x="6977700" y="6581001"/>
+            <a:ext cx="2719674" cy="276999"/>
+          </a:xfrm>
+          <a:prstGeom prst="rect">
+            <a:avLst/>
+          </a:prstGeom>
+          <a:noFill/>
+        </p:spPr>
+        <p:txBody>
+          <a:bodyPr wrap="square">
+            <a:spAutoFit/>
+          </a:bodyPr>
+          <a:lstStyle/>
+          <a:p>
+            <a:pPr algn="ctr"/>
+            <a:r>
+              <a:rPr lang="zh-CN" altLang="en-US" sz="1200" b="1" dirty="0">
+                <a:solidFill>
+                  <a:schemeClr val="accent1"/>
+                </a:solidFill>
+                <a:latin typeface="Arial" panose="020B0604020202020204" pitchFamily="34" charset="0"/>
+                <a:sym typeface="+mn-ea"/>
+              </a:rPr>
+              <a:t>短堆台架测试拟合</a:t>
+            </a:r>
+            <a:endParaRPr lang="zh-CN" altLang="en-US" sz="1200" b="1" dirty="0"/>
+          </a:p>
+        </p:txBody>
+      </p:sp>
+      <p:sp>
+        <p:nvSpPr>
+          <p:cNvPr id="10" name="文本框 9">
+            <a:extLst>
+              <a:ext uri="{FF2B5EF4-FFF2-40B4-BE49-F238E27FC236}">
+                <a16:creationId xmlns:a16="http://schemas.microsoft.com/office/drawing/2014/main" id="{9B26D5F4-1FA9-C43C-3E2C-8CF0679DD528}"/>
+              </a:ext>
+            </a:extLst>
+          </p:cNvPr>
+          <p:cNvSpPr txBox="1"/>
+          <p:nvPr/>
+        </p:nvSpPr>
+        <p:spPr>
+          <a:xfrm>
+            <a:off x="7768103" y="4092191"/>
+            <a:ext cx="360040" cy="249681"/>
+          </a:xfrm>
+          <a:prstGeom prst="rect">
+            <a:avLst/>
+          </a:prstGeom>
+          <a:noFill/>
+        </p:spPr>
+        <p:txBody>
+          <a:bodyPr wrap="none" lIns="36000" tIns="36000" rIns="36000" bIns="36000" rtlCol="0">
+            <a:noAutofit/>
+          </a:bodyPr>
+          <a:lstStyle/>
+          <a:p>
+            <a:pPr algn="l">
+              <a:spcBef>
+                <a:spcPts val="600"/>
+              </a:spcBef>
+            </a:pPr>
+            <a:r>
+              <a:rPr lang="en-US" altLang="zh-CN" sz="1100" dirty="0">
+                <a:solidFill>
+                  <a:schemeClr val="accent4"/>
+                </a:solidFill>
+                <a:latin typeface="+mj-lt"/>
+              </a:rPr>
+              <a:t>1.</a:t>
+            </a:r>
+            <a:r>
+              <a:rPr lang="zh-CN" altLang="en-US" sz="1100" dirty="0">
+                <a:solidFill>
+                  <a:schemeClr val="accent4"/>
+                </a:solidFill>
+                <a:latin typeface="+mj-lt"/>
+              </a:rPr>
+              <a:t>电压</a:t>
+            </a:r>
+          </a:p>
+        </p:txBody>
+      </p:sp>
+      <p:sp>
+        <p:nvSpPr>
+          <p:cNvPr id="11" name="文本框 10">
+            <a:extLst>
+              <a:ext uri="{FF2B5EF4-FFF2-40B4-BE49-F238E27FC236}">
+                <a16:creationId xmlns:a16="http://schemas.microsoft.com/office/drawing/2014/main" id="{DBE1AE68-7E28-A8FD-B317-FE2A813FB0EE}"/>
+              </a:ext>
+            </a:extLst>
+          </p:cNvPr>
+          <p:cNvSpPr txBox="1"/>
+          <p:nvPr/>
+        </p:nvSpPr>
+        <p:spPr>
+          <a:xfrm>
+            <a:off x="8470776" y="4092191"/>
+            <a:ext cx="360040" cy="249681"/>
+          </a:xfrm>
+          <a:prstGeom prst="rect">
+            <a:avLst/>
+          </a:prstGeom>
+          <a:noFill/>
+        </p:spPr>
+        <p:txBody>
+          <a:bodyPr wrap="none" lIns="36000" tIns="36000" rIns="36000" bIns="36000" rtlCol="0">
+            <a:noAutofit/>
+          </a:bodyPr>
+          <a:lstStyle/>
+          <a:p>
+            <a:pPr algn="l">
+              <a:spcBef>
+                <a:spcPts val="600"/>
+              </a:spcBef>
+            </a:pPr>
+            <a:r>
+              <a:rPr lang="en-US" altLang="zh-CN" sz="1100" dirty="0">
+                <a:solidFill>
+                  <a:schemeClr val="accent4"/>
+                </a:solidFill>
+                <a:latin typeface="+mj-lt"/>
+              </a:rPr>
+              <a:t>2.</a:t>
+            </a:r>
+            <a:r>
+              <a:rPr lang="zh-CN" altLang="en-US" sz="1100" dirty="0">
+                <a:solidFill>
+                  <a:schemeClr val="accent4"/>
+                </a:solidFill>
+                <a:latin typeface="+mj-lt"/>
+              </a:rPr>
+              <a:t>温度</a:t>
+            </a:r>
+          </a:p>
+        </p:txBody>
+      </p:sp>
+      <p:sp>
+        <p:nvSpPr>
+          <p:cNvPr id="12" name="文本框 11">
+            <a:extLst>
+              <a:ext uri="{FF2B5EF4-FFF2-40B4-BE49-F238E27FC236}">
+                <a16:creationId xmlns:a16="http://schemas.microsoft.com/office/drawing/2014/main" id="{195AA039-270C-5F11-E52D-DA055CC8911E}"/>
+              </a:ext>
+            </a:extLst>
+          </p:cNvPr>
+          <p:cNvSpPr txBox="1"/>
+          <p:nvPr/>
+        </p:nvSpPr>
+        <p:spPr>
+          <a:xfrm>
+            <a:off x="7768103" y="5354678"/>
+            <a:ext cx="360040" cy="249681"/>
+          </a:xfrm>
+          <a:prstGeom prst="rect">
+            <a:avLst/>
+          </a:prstGeom>
+          <a:noFill/>
+        </p:spPr>
+        <p:txBody>
+          <a:bodyPr wrap="none" lIns="36000" tIns="36000" rIns="36000" bIns="36000" rtlCol="0">
+            <a:noAutofit/>
+          </a:bodyPr>
+          <a:lstStyle/>
+          <a:p>
+            <a:pPr algn="l">
+              <a:spcBef>
+                <a:spcPts val="600"/>
+              </a:spcBef>
+            </a:pPr>
+            <a:r>
+              <a:rPr lang="en-US" altLang="zh-CN" sz="1100" dirty="0">
+                <a:solidFill>
+                  <a:schemeClr val="accent4"/>
+                </a:solidFill>
+                <a:latin typeface="+mj-lt"/>
+              </a:rPr>
+              <a:t>3.</a:t>
+            </a:r>
+            <a:r>
+              <a:rPr lang="zh-CN" altLang="en-US" sz="1100" dirty="0">
+                <a:solidFill>
+                  <a:schemeClr val="accent4"/>
+                </a:solidFill>
+                <a:latin typeface="+mj-lt"/>
+              </a:rPr>
+              <a:t>压力</a:t>
+            </a:r>
+          </a:p>
+        </p:txBody>
+      </p:sp>
+      <p:sp>
+        <p:nvSpPr>
+          <p:cNvPr id="13" name="文本框 12">
+            <a:extLst>
+              <a:ext uri="{FF2B5EF4-FFF2-40B4-BE49-F238E27FC236}">
+                <a16:creationId xmlns:a16="http://schemas.microsoft.com/office/drawing/2014/main" id="{96E0B639-38C4-04E0-62AC-F2038AF2A401}"/>
+              </a:ext>
+            </a:extLst>
+          </p:cNvPr>
+          <p:cNvSpPr txBox="1"/>
+          <p:nvPr/>
+        </p:nvSpPr>
+        <p:spPr>
+          <a:xfrm>
+            <a:off x="8472264" y="5348425"/>
+            <a:ext cx="360040" cy="249681"/>
+          </a:xfrm>
+          <a:prstGeom prst="rect">
+            <a:avLst/>
+          </a:prstGeom>
+          <a:noFill/>
+        </p:spPr>
+        <p:txBody>
+          <a:bodyPr wrap="none" lIns="36000" tIns="36000" rIns="36000" bIns="36000" rtlCol="0">
+            <a:noAutofit/>
+          </a:bodyPr>
+          <a:lstStyle/>
+          <a:p>
+            <a:pPr algn="l">
+              <a:spcBef>
+                <a:spcPts val="600"/>
+              </a:spcBef>
+            </a:pPr>
+            <a:r>
+              <a:rPr lang="en-US" altLang="zh-CN" sz="1100" dirty="0">
+                <a:solidFill>
+                  <a:schemeClr val="accent4"/>
+                </a:solidFill>
+                <a:latin typeface="+mj-lt"/>
+              </a:rPr>
+              <a:t>4.</a:t>
+            </a:r>
+            <a:r>
+              <a:rPr lang="zh-CN" altLang="en-US" sz="1100" dirty="0">
+                <a:solidFill>
+                  <a:schemeClr val="accent4"/>
+                </a:solidFill>
+                <a:latin typeface="+mj-lt"/>
+              </a:rPr>
+              <a:t>湿度</a:t>
+            </a:r>
+          </a:p>
+        </p:txBody>
+      </p:sp>
+      <p:sp>
+        <p:nvSpPr>
+          <p:cNvPr id="22" name="文本框 21">
+            <a:extLst>
+              <a:ext uri="{FF2B5EF4-FFF2-40B4-BE49-F238E27FC236}">
+                <a16:creationId xmlns:a16="http://schemas.microsoft.com/office/drawing/2014/main" id="{82A121D8-CE55-7A40-24D4-24544515D939}"/>
+              </a:ext>
+            </a:extLst>
+          </p:cNvPr>
+          <p:cNvSpPr txBox="1"/>
+          <p:nvPr/>
+        </p:nvSpPr>
+        <p:spPr>
+          <a:xfrm>
+            <a:off x="6965347" y="3578080"/>
+            <a:ext cx="2719674" cy="276999"/>
+          </a:xfrm>
+          <a:prstGeom prst="rect">
+            <a:avLst/>
+          </a:prstGeom>
+          <a:noFill/>
+        </p:spPr>
+        <p:txBody>
+          <a:bodyPr wrap="square">
+            <a:spAutoFit/>
+          </a:bodyPr>
+          <a:lstStyle/>
+          <a:p>
+            <a:pPr algn="ctr"/>
+            <a:r>
+              <a:rPr lang="zh-CN" altLang="en-US" sz="1200" b="1" dirty="0">
+                <a:solidFill>
+                  <a:schemeClr val="accent1"/>
+                </a:solidFill>
+                <a:latin typeface="Arial" panose="020B0604020202020204" pitchFamily="34" charset="0"/>
+                <a:sym typeface="+mn-ea"/>
+              </a:rPr>
+              <a:t>模块计算内容</a:t>
+            </a:r>
+            <a:endParaRPr lang="zh-CN" altLang="en-US" sz="1200" b="1" dirty="0"/>
+          </a:p>
+        </p:txBody>
+      </p:sp>
+      <p:cxnSp>
+        <p:nvCxnSpPr>
+          <p:cNvPr id="23" name="直接连接符 22">
+            <a:extLst>
+              <a:ext uri="{FF2B5EF4-FFF2-40B4-BE49-F238E27FC236}">
+                <a16:creationId xmlns:a16="http://schemas.microsoft.com/office/drawing/2014/main" id="{12C85996-579B-DE1A-B6BF-31969286D1B0}"/>
+              </a:ext>
+            </a:extLst>
+          </p:cNvPr>
+          <p:cNvCxnSpPr/>
+          <p:nvPr/>
+        </p:nvCxnSpPr>
+        <p:spPr>
+          <a:xfrm>
+            <a:off x="4799856" y="1730843"/>
+            <a:ext cx="0" cy="4248472"/>
+          </a:xfrm>
+          <a:prstGeom prst="line">
+            <a:avLst/>
+          </a:prstGeom>
+          <a:ln>
+            <a:prstDash val="lgDash"/>
+          </a:ln>
+        </p:spPr>
+        <p:style>
+          <a:lnRef idx="1">
+            <a:schemeClr val="accent1"/>
+          </a:lnRef>
+          <a:fillRef idx="0">
+            <a:schemeClr val="accent1"/>
+          </a:fillRef>
+          <a:effectRef idx="0">
+            <a:schemeClr val="accent1"/>
+          </a:effectRef>
+          <a:fontRef idx="minor">
+            <a:schemeClr val="tx1"/>
+          </a:fontRef>
+        </p:style>
+      </p:cxnSp>
+    </p:spTree>
+    <p:extLst>
+      <p:ext uri="{BB962C8B-B14F-4D97-AF65-F5344CB8AC3E}">
+        <p14:creationId xmlns:p14="http://schemas.microsoft.com/office/powerpoint/2010/main" val="2789912691"/>
+      </p:ext>
+    </p:extLst>
+  </p:cSld>
+  <p:clrMapOvr>
+    <a:masterClrMapping/>
+  </p:clrMapOvr>
+</p:sld>
+</file>
+
+<file path=ppt/slides/slide6.xml><?xml version="1.0" encoding="utf-8"?>
+<p:sld xmlns:a="http://schemas.openxmlformats.org/drawingml/2006/main" xmlns:r="http://schemas.openxmlformats.org/officeDocument/2006/relationships" xmlns:p="http://schemas.openxmlformats.org/presentationml/2006/main">
+  <p:cSld>
+    <p:spTree>
+      <p:nvGrpSpPr>
+        <p:cNvPr id="1" name="">
+          <a:extLst>
+            <a:ext uri="{FF2B5EF4-FFF2-40B4-BE49-F238E27FC236}">
+              <a16:creationId xmlns:a16="http://schemas.microsoft.com/office/drawing/2014/main" id="{22AB564B-4D23-0C5B-9E34-F9C8C9FB4F2D}"/>
+            </a:ext>
+          </a:extLst>
+        </p:cNvPr>
+        <p:cNvGrpSpPr/>
+        <p:nvPr/>
+      </p:nvGrpSpPr>
+      <p:grpSpPr>
+        <a:xfrm>
+          <a:off x="0" y="0"/>
+          <a:ext cx="0" cy="0"/>
+          <a:chOff x="0" y="0"/>
+          <a:chExt cx="0" cy="0"/>
+        </a:xfrm>
+      </p:grpSpPr>
+      <p:pic>
+        <p:nvPicPr>
+          <p:cNvPr id="11" name="图片 10">
+            <a:extLst>
+              <a:ext uri="{FF2B5EF4-FFF2-40B4-BE49-F238E27FC236}">
+                <a16:creationId xmlns:a16="http://schemas.microsoft.com/office/drawing/2014/main" id="{285B6600-9A61-9766-D2A9-9668DD6C0251}"/>
+              </a:ext>
+            </a:extLst>
+          </p:cNvPr>
+          <p:cNvPicPr>
+            <a:picLocks noChangeAspect="1"/>
+          </p:cNvPicPr>
+          <p:nvPr/>
+        </p:nvPicPr>
+        <p:blipFill>
+          <a:blip r:embed="rId3" cstate="print">
+            <a:extLst>
+              <a:ext uri="{28A0092B-C50C-407E-A947-70E740481C1C}">
+                <a14:useLocalDpi xmlns:a14="http://schemas.microsoft.com/office/drawing/2010/main" val="0"/>
+              </a:ext>
+            </a:extLst>
+          </a:blip>
+          <a:stretch>
+            <a:fillRect/>
+          </a:stretch>
+        </p:blipFill>
+        <p:spPr>
+          <a:xfrm>
+            <a:off x="578272" y="1412818"/>
+            <a:ext cx="10637751" cy="5025600"/>
+          </a:xfrm>
+          <a:prstGeom prst="rect">
+            <a:avLst/>
+          </a:prstGeom>
+        </p:spPr>
+      </p:pic>
+      <p:sp>
+        <p:nvSpPr>
+          <p:cNvPr id="2" name="文本占位符 1">
+            <a:extLst>
+              <a:ext uri="{FF2B5EF4-FFF2-40B4-BE49-F238E27FC236}">
+                <a16:creationId xmlns:a16="http://schemas.microsoft.com/office/drawing/2014/main" id="{D26EFD4F-4DFA-960C-C715-082B2CEE517C}"/>
+              </a:ext>
+            </a:extLst>
+          </p:cNvPr>
+          <p:cNvSpPr>
+            <a:spLocks noGrp="1"/>
+          </p:cNvSpPr>
+          <p:nvPr>
+            <p:ph type="body" sz="quarter" idx="12"/>
+          </p:nvPr>
+        </p:nvSpPr>
+        <p:spPr/>
+        <p:txBody>
+          <a:bodyPr wrap="square"/>
+          <a:lstStyle/>
+          <a:p>
+            <a:r>
+              <a:rPr lang="zh-CN" altLang="en-US" sz="2400" dirty="0">
+                <a:solidFill>
+                  <a:schemeClr val="accent1"/>
+                </a:solidFill>
+                <a:latin typeface="Arial" panose="020B0604020202020204" pitchFamily="34" charset="0"/>
+                <a:sym typeface="+mn-ea"/>
+              </a:rPr>
+              <a:t>台架结构仿真结果</a:t>
+            </a:r>
+            <a:r>
+              <a:rPr lang="en-US" altLang="zh-CN" sz="2400" dirty="0">
+                <a:solidFill>
+                  <a:schemeClr val="accent1"/>
+                </a:solidFill>
+                <a:latin typeface="Arial" panose="020B0604020202020204" pitchFamily="34" charset="0"/>
+                <a:sym typeface="+mn-ea"/>
+              </a:rPr>
+              <a:t>1</a:t>
+            </a:r>
+            <a:endParaRPr lang="zh-CN" altLang="en-US" sz="2400" dirty="0">
+              <a:solidFill>
+                <a:schemeClr val="accent1"/>
+              </a:solidFill>
+              <a:latin typeface="Arial" panose="020B0604020202020204" pitchFamily="34" charset="0"/>
+              <a:sym typeface="+mn-ea"/>
+            </a:endParaRPr>
+          </a:p>
+        </p:txBody>
+      </p:sp>
+      <p:sp>
+        <p:nvSpPr>
+          <p:cNvPr id="18" name="文本框 17">
+            <a:extLst>
+              <a:ext uri="{FF2B5EF4-FFF2-40B4-BE49-F238E27FC236}">
+                <a16:creationId xmlns:a16="http://schemas.microsoft.com/office/drawing/2014/main" id="{E185CEE3-9115-F956-7C8B-C9790F035DD7}"/>
+              </a:ext>
+            </a:extLst>
+          </p:cNvPr>
+          <p:cNvSpPr txBox="1"/>
+          <p:nvPr/>
+        </p:nvSpPr>
+        <p:spPr>
+          <a:xfrm>
+            <a:off x="477723" y="957028"/>
+            <a:ext cx="6480720" cy="307777"/>
+          </a:xfrm>
+          <a:prstGeom prst="rect">
+            <a:avLst/>
+          </a:prstGeom>
+          <a:noFill/>
+        </p:spPr>
+        <p:txBody>
+          <a:bodyPr wrap="square">
+            <a:spAutoFit/>
+          </a:bodyPr>
+          <a:lstStyle/>
+          <a:p>
+            <a:pPr marL="285750" indent="-285750">
+              <a:buFont typeface="Wingdings" panose="05000000000000000000" pitchFamily="2" charset="2"/>
+              <a:buChar char="p"/>
+            </a:pPr>
+            <a:r>
+              <a:rPr lang="zh-CN" altLang="en-US" sz="1400" b="1" dirty="0">
+                <a:solidFill>
+                  <a:srgbClr val="152A8C"/>
+                </a:solidFill>
+                <a:latin typeface="Arial" panose="020B0604020202020204" pitchFamily="34" charset="0"/>
+                <a:ea typeface="微软雅黑" panose="020B0503020204020204" pitchFamily="34" charset="-122"/>
+              </a:rPr>
+              <a:t>恒电流</a:t>
+            </a:r>
+            <a:r>
+              <a:rPr lang="en-US" altLang="zh-CN" sz="1400" b="1" dirty="0">
+                <a:solidFill>
+                  <a:srgbClr val="152A8C"/>
+                </a:solidFill>
+                <a:latin typeface="Arial" panose="020B0604020202020204" pitchFamily="34" charset="0"/>
+                <a:ea typeface="微软雅黑" panose="020B0503020204020204" pitchFamily="34" charset="-122"/>
+              </a:rPr>
+              <a:t>EGR</a:t>
+            </a:r>
+            <a:r>
+              <a:rPr lang="zh-CN" altLang="en-US" sz="1400" b="1" dirty="0">
+                <a:solidFill>
+                  <a:srgbClr val="152A8C"/>
+                </a:solidFill>
+                <a:latin typeface="Arial" panose="020B0604020202020204" pitchFamily="34" charset="0"/>
+                <a:ea typeface="微软雅黑" panose="020B0503020204020204" pitchFamily="34" charset="-122"/>
+              </a:rPr>
+              <a:t>扫描（</a:t>
+            </a:r>
+            <a:r>
+              <a:rPr lang="en-US" altLang="zh-CN" sz="1400" b="1" dirty="0">
+                <a:solidFill>
+                  <a:srgbClr val="152A8C"/>
+                </a:solidFill>
+                <a:latin typeface="Arial" panose="020B0604020202020204" pitchFamily="34" charset="0"/>
+                <a:ea typeface="微软雅黑" panose="020B0503020204020204" pitchFamily="34" charset="-122"/>
+              </a:rPr>
+              <a:t>0.1</a:t>
+            </a:r>
+            <a:r>
+              <a:rPr lang="zh-CN" altLang="en-US" sz="1400" b="1" dirty="0">
+                <a:solidFill>
+                  <a:srgbClr val="152A8C"/>
+                </a:solidFill>
+                <a:latin typeface="Arial" panose="020B0604020202020204" pitchFamily="34" charset="0"/>
+                <a:ea typeface="微软雅黑" panose="020B0503020204020204" pitchFamily="34" charset="-122"/>
+              </a:rPr>
+              <a:t>、</a:t>
+            </a:r>
+            <a:r>
+              <a:rPr lang="en-US" altLang="zh-CN" sz="1400" b="1" dirty="0">
+                <a:solidFill>
+                  <a:srgbClr val="152A8C"/>
+                </a:solidFill>
+                <a:latin typeface="Arial" panose="020B0604020202020204" pitchFamily="34" charset="0"/>
+                <a:ea typeface="微软雅黑" panose="020B0503020204020204" pitchFamily="34" charset="-122"/>
+              </a:rPr>
+              <a:t>0.2</a:t>
+            </a:r>
+            <a:r>
+              <a:rPr lang="zh-CN" altLang="en-US" sz="1400" b="1" dirty="0">
+                <a:solidFill>
+                  <a:srgbClr val="152A8C"/>
+                </a:solidFill>
+                <a:latin typeface="Arial" panose="020B0604020202020204" pitchFamily="34" charset="0"/>
+                <a:ea typeface="微软雅黑" panose="020B0503020204020204" pitchFamily="34" charset="-122"/>
+              </a:rPr>
+              <a:t>、</a:t>
+            </a:r>
+            <a:r>
+              <a:rPr lang="en-US" altLang="zh-CN" sz="1400" b="1" dirty="0">
+                <a:solidFill>
+                  <a:srgbClr val="152A8C"/>
+                </a:solidFill>
+                <a:latin typeface="Arial" panose="020B0604020202020204" pitchFamily="34" charset="0"/>
+                <a:ea typeface="微软雅黑" panose="020B0503020204020204" pitchFamily="34" charset="-122"/>
+              </a:rPr>
+              <a:t>0.3 A/cm</a:t>
+            </a:r>
+            <a:r>
+              <a:rPr lang="en-US" altLang="zh-CN" sz="1400" b="1" baseline="30000" dirty="0">
+                <a:solidFill>
+                  <a:srgbClr val="152A8C"/>
+                </a:solidFill>
+                <a:latin typeface="Arial" panose="020B0604020202020204" pitchFamily="34" charset="0"/>
+                <a:ea typeface="微软雅黑" panose="020B0503020204020204" pitchFamily="34" charset="-122"/>
+              </a:rPr>
+              <a:t>2</a:t>
+            </a:r>
+            <a:r>
+              <a:rPr lang="zh-CN" altLang="en-US" sz="1400" b="1" dirty="0">
+                <a:solidFill>
+                  <a:srgbClr val="152A8C"/>
+                </a:solidFill>
+                <a:latin typeface="Arial" panose="020B0604020202020204" pitchFamily="34" charset="0"/>
+                <a:ea typeface="微软雅黑" panose="020B0503020204020204" pitchFamily="34" charset="-122"/>
+              </a:rPr>
+              <a:t>）：看氧稀释和电压下降</a:t>
+            </a:r>
+          </a:p>
+        </p:txBody>
+      </p:sp>
+      <p:sp>
+        <p:nvSpPr>
+          <p:cNvPr id="4" name="文本框 3">
+            <a:extLst>
+              <a:ext uri="{FF2B5EF4-FFF2-40B4-BE49-F238E27FC236}">
+                <a16:creationId xmlns:a16="http://schemas.microsoft.com/office/drawing/2014/main" id="{6FF9F0C1-4FFB-D26B-75F0-1D673AA1F8DF}"/>
+              </a:ext>
+            </a:extLst>
+          </p:cNvPr>
+          <p:cNvSpPr txBox="1"/>
+          <p:nvPr/>
+        </p:nvSpPr>
+        <p:spPr>
+          <a:xfrm>
+            <a:off x="2207568" y="1896410"/>
+            <a:ext cx="914400" cy="914400"/>
+          </a:xfrm>
+          <a:prstGeom prst="rect">
+            <a:avLst/>
+          </a:prstGeom>
+          <a:noFill/>
+        </p:spPr>
+        <p:txBody>
+          <a:bodyPr wrap="none" lIns="36000" tIns="36000" rIns="36000" bIns="36000" rtlCol="0">
+            <a:noAutofit/>
+          </a:bodyPr>
+          <a:lstStyle/>
+          <a:p>
+            <a:pPr algn="ctr">
+              <a:spcBef>
+                <a:spcPts val="600"/>
+              </a:spcBef>
+            </a:pPr>
+            <a:r>
+              <a:rPr lang="en-US" altLang="zh-CN" sz="1400" dirty="0">
+                <a:solidFill>
+                  <a:schemeClr val="accent4"/>
+                </a:solidFill>
+                <a:latin typeface="+mj-lt"/>
+              </a:rPr>
+              <a:t>1.</a:t>
+            </a:r>
+            <a:r>
+              <a:rPr lang="zh-CN" altLang="en-US" sz="1400" dirty="0">
+                <a:solidFill>
+                  <a:schemeClr val="accent4"/>
+                </a:solidFill>
+                <a:latin typeface="+mj-lt"/>
+              </a:rPr>
+              <a:t>电压</a:t>
+            </a:r>
+          </a:p>
+        </p:txBody>
+      </p:sp>
+      <p:sp>
+        <p:nvSpPr>
+          <p:cNvPr id="5" name="文本框 4">
+            <a:extLst>
+              <a:ext uri="{FF2B5EF4-FFF2-40B4-BE49-F238E27FC236}">
+                <a16:creationId xmlns:a16="http://schemas.microsoft.com/office/drawing/2014/main" id="{7977E515-B476-265B-B5D7-1C8D260BFF57}"/>
+              </a:ext>
+            </a:extLst>
+          </p:cNvPr>
+          <p:cNvSpPr txBox="1"/>
+          <p:nvPr/>
+        </p:nvSpPr>
+        <p:spPr>
+          <a:xfrm>
+            <a:off x="5638800" y="1896410"/>
+            <a:ext cx="914400" cy="914400"/>
+          </a:xfrm>
+          <a:prstGeom prst="rect">
+            <a:avLst/>
+          </a:prstGeom>
+          <a:noFill/>
+        </p:spPr>
+        <p:txBody>
+          <a:bodyPr wrap="none" lIns="36000" tIns="36000" rIns="36000" bIns="36000" rtlCol="0">
+            <a:noAutofit/>
+          </a:bodyPr>
+          <a:lstStyle/>
+          <a:p>
+            <a:pPr algn="ctr">
+              <a:spcBef>
+                <a:spcPts val="600"/>
+              </a:spcBef>
+            </a:pPr>
+            <a:r>
+              <a:rPr lang="en-US" altLang="zh-CN" sz="1400" dirty="0">
+                <a:solidFill>
+                  <a:schemeClr val="accent4"/>
+                </a:solidFill>
+                <a:latin typeface="+mj-lt"/>
+              </a:rPr>
+              <a:t>2.</a:t>
+            </a:r>
+            <a:r>
+              <a:rPr lang="zh-CN" altLang="en-US" sz="1400" dirty="0">
+                <a:solidFill>
+                  <a:schemeClr val="accent4"/>
+                </a:solidFill>
+                <a:latin typeface="+mj-lt"/>
+              </a:rPr>
+              <a:t>功率</a:t>
+            </a:r>
+          </a:p>
+        </p:txBody>
+      </p:sp>
+      <p:sp>
+        <p:nvSpPr>
+          <p:cNvPr id="6" name="文本框 5">
+            <a:extLst>
+              <a:ext uri="{FF2B5EF4-FFF2-40B4-BE49-F238E27FC236}">
+                <a16:creationId xmlns:a16="http://schemas.microsoft.com/office/drawing/2014/main" id="{A894004E-2570-6E83-AAEE-DF82070F98F0}"/>
+              </a:ext>
+            </a:extLst>
+          </p:cNvPr>
+          <p:cNvSpPr txBox="1"/>
+          <p:nvPr/>
+        </p:nvSpPr>
+        <p:spPr>
+          <a:xfrm>
+            <a:off x="9070032" y="1896410"/>
+            <a:ext cx="914400" cy="914400"/>
+          </a:xfrm>
+          <a:prstGeom prst="rect">
+            <a:avLst/>
+          </a:prstGeom>
+          <a:noFill/>
+        </p:spPr>
+        <p:txBody>
+          <a:bodyPr wrap="none" lIns="36000" tIns="36000" rIns="36000" bIns="36000" rtlCol="0">
+            <a:noAutofit/>
+          </a:bodyPr>
+          <a:lstStyle/>
+          <a:p>
+            <a:pPr algn="ctr">
+              <a:spcBef>
+                <a:spcPts val="600"/>
+              </a:spcBef>
+            </a:pPr>
+            <a:r>
+              <a:rPr lang="en-US" altLang="zh-CN" sz="1400" dirty="0">
+                <a:solidFill>
+                  <a:schemeClr val="accent4"/>
+                </a:solidFill>
+                <a:latin typeface="+mj-lt"/>
+              </a:rPr>
+              <a:t>3.</a:t>
+            </a:r>
+            <a:r>
+              <a:rPr lang="zh-CN" altLang="en-US" sz="1400" dirty="0">
+                <a:solidFill>
+                  <a:schemeClr val="accent4"/>
+                </a:solidFill>
+                <a:latin typeface="+mj-lt"/>
+              </a:rPr>
+              <a:t>氧分压</a:t>
+            </a:r>
+          </a:p>
+        </p:txBody>
+      </p:sp>
+      <p:sp>
+        <p:nvSpPr>
+          <p:cNvPr id="7" name="文本框 6">
+            <a:extLst>
+              <a:ext uri="{FF2B5EF4-FFF2-40B4-BE49-F238E27FC236}">
+                <a16:creationId xmlns:a16="http://schemas.microsoft.com/office/drawing/2014/main" id="{A9FCE127-FD01-5000-5944-2DBA477068B7}"/>
+              </a:ext>
+            </a:extLst>
+          </p:cNvPr>
+          <p:cNvSpPr txBox="1"/>
+          <p:nvPr/>
+        </p:nvSpPr>
+        <p:spPr>
+          <a:xfrm>
+            <a:off x="2156139" y="4313220"/>
+            <a:ext cx="914400" cy="914400"/>
+          </a:xfrm>
+          <a:prstGeom prst="rect">
+            <a:avLst/>
+          </a:prstGeom>
+          <a:noFill/>
+        </p:spPr>
+        <p:txBody>
+          <a:bodyPr wrap="none" lIns="36000" tIns="36000" rIns="36000" bIns="36000" rtlCol="0">
+            <a:noAutofit/>
+          </a:bodyPr>
+          <a:lstStyle/>
+          <a:p>
+            <a:pPr algn="ctr">
+              <a:spcBef>
+                <a:spcPts val="600"/>
+              </a:spcBef>
+            </a:pPr>
+            <a:r>
+              <a:rPr lang="en-US" altLang="zh-CN" sz="1400" dirty="0">
+                <a:solidFill>
+                  <a:schemeClr val="accent4"/>
+                </a:solidFill>
+                <a:latin typeface="+mj-lt"/>
+              </a:rPr>
+              <a:t>4.</a:t>
+            </a:r>
+            <a:r>
+              <a:rPr lang="zh-CN" altLang="en-US" sz="1400" dirty="0">
+                <a:solidFill>
+                  <a:schemeClr val="accent4"/>
+                </a:solidFill>
+                <a:latin typeface="+mj-lt"/>
+              </a:rPr>
+              <a:t>氧计量比</a:t>
+            </a:r>
+          </a:p>
+        </p:txBody>
+      </p:sp>
+      <p:sp>
+        <p:nvSpPr>
+          <p:cNvPr id="8" name="文本框 7">
+            <a:extLst>
+              <a:ext uri="{FF2B5EF4-FFF2-40B4-BE49-F238E27FC236}">
+                <a16:creationId xmlns:a16="http://schemas.microsoft.com/office/drawing/2014/main" id="{99160706-8E09-C522-A3FB-F15AA23AC865}"/>
+              </a:ext>
+            </a:extLst>
+          </p:cNvPr>
+          <p:cNvSpPr txBox="1"/>
+          <p:nvPr/>
+        </p:nvSpPr>
+        <p:spPr>
+          <a:xfrm>
+            <a:off x="5638800" y="4313220"/>
+            <a:ext cx="914400" cy="914400"/>
+          </a:xfrm>
+          <a:prstGeom prst="rect">
+            <a:avLst/>
+          </a:prstGeom>
+          <a:noFill/>
+        </p:spPr>
+        <p:txBody>
+          <a:bodyPr wrap="none" lIns="36000" tIns="36000" rIns="36000" bIns="36000" rtlCol="0">
+            <a:noAutofit/>
+          </a:bodyPr>
+          <a:lstStyle/>
+          <a:p>
+            <a:pPr algn="ctr">
+              <a:spcBef>
+                <a:spcPts val="600"/>
+              </a:spcBef>
+            </a:pPr>
+            <a:r>
+              <a:rPr lang="en-US" altLang="zh-CN" sz="1400" dirty="0">
+                <a:solidFill>
+                  <a:schemeClr val="accent4"/>
+                </a:solidFill>
+                <a:latin typeface="+mj-lt"/>
+              </a:rPr>
+              <a:t>5.</a:t>
+            </a:r>
+            <a:r>
+              <a:rPr lang="zh-CN" altLang="en-US" sz="1400" dirty="0">
+                <a:solidFill>
+                  <a:schemeClr val="accent4"/>
+                </a:solidFill>
+                <a:latin typeface="+mj-lt"/>
+              </a:rPr>
+              <a:t>相对湿度</a:t>
+            </a:r>
+          </a:p>
+        </p:txBody>
+      </p:sp>
+      <p:sp>
+        <p:nvSpPr>
+          <p:cNvPr id="9" name="文本框 8">
+            <a:extLst>
+              <a:ext uri="{FF2B5EF4-FFF2-40B4-BE49-F238E27FC236}">
+                <a16:creationId xmlns:a16="http://schemas.microsoft.com/office/drawing/2014/main" id="{71CBBE68-BC66-BFBE-0EF4-3398A1C3C87A}"/>
+              </a:ext>
+            </a:extLst>
+          </p:cNvPr>
+          <p:cNvSpPr txBox="1"/>
+          <p:nvPr/>
+        </p:nvSpPr>
+        <p:spPr>
+          <a:xfrm>
+            <a:off x="9070032" y="4313220"/>
+            <a:ext cx="914400" cy="914400"/>
+          </a:xfrm>
+          <a:prstGeom prst="rect">
+            <a:avLst/>
+          </a:prstGeom>
+          <a:noFill/>
+        </p:spPr>
+        <p:txBody>
+          <a:bodyPr wrap="none" lIns="36000" tIns="36000" rIns="36000" bIns="36000" rtlCol="0">
+            <a:noAutofit/>
+          </a:bodyPr>
+          <a:lstStyle/>
+          <a:p>
+            <a:pPr algn="ctr">
+              <a:spcBef>
+                <a:spcPts val="600"/>
+              </a:spcBef>
+            </a:pPr>
+            <a:r>
+              <a:rPr lang="en-US" altLang="zh-CN" sz="1400" dirty="0">
+                <a:solidFill>
+                  <a:schemeClr val="accent4"/>
+                </a:solidFill>
+                <a:latin typeface="+mj-lt"/>
+              </a:rPr>
+              <a:t>6.</a:t>
+            </a:r>
+            <a:r>
+              <a:rPr lang="zh-CN" altLang="en-US" sz="1400" dirty="0">
+                <a:solidFill>
+                  <a:schemeClr val="accent4"/>
+                </a:solidFill>
+                <a:latin typeface="+mj-lt"/>
+              </a:rPr>
+              <a:t>温度</a:t>
+            </a:r>
+          </a:p>
+        </p:txBody>
+      </p:sp>
+    </p:spTree>
+    <p:extLst>
+      <p:ext uri="{BB962C8B-B14F-4D97-AF65-F5344CB8AC3E}">
+        <p14:creationId xmlns:p14="http://schemas.microsoft.com/office/powerpoint/2010/main" val="3505770488"/>
+      </p:ext>
+    </p:extLst>
+  </p:cSld>
+  <p:clrMapOvr>
+    <a:masterClrMapping/>
+  </p:clrMapOvr>
+</p:sld>
+</file>
+
+<file path=ppt/slides/slide7.xml><?xml version="1.0" encoding="utf-8"?>
+<p:sld xmlns:a="http://schemas.openxmlformats.org/drawingml/2006/main" xmlns:r="http://schemas.openxmlformats.org/officeDocument/2006/relationships" xmlns:p="http://schemas.openxmlformats.org/presentationml/2006/main">
+  <p:cSld>
+    <p:spTree>
+      <p:nvGrpSpPr>
+        <p:cNvPr id="1" name="">
+          <a:extLst>
+            <a:ext uri="{FF2B5EF4-FFF2-40B4-BE49-F238E27FC236}">
+              <a16:creationId xmlns:a16="http://schemas.microsoft.com/office/drawing/2014/main" id="{0E71EDB8-D602-3E4A-5051-39A6D6ECE7FA}"/>
+            </a:ext>
+          </a:extLst>
+        </p:cNvPr>
+        <p:cNvGrpSpPr/>
+        <p:nvPr/>
+      </p:nvGrpSpPr>
+      <p:grpSpPr>
+        <a:xfrm>
+          <a:off x="0" y="0"/>
+          <a:ext cx="0" cy="0"/>
+          <a:chOff x="0" y="0"/>
+          <a:chExt cx="0" cy="0"/>
+        </a:xfrm>
+      </p:grpSpPr>
+      <p:pic>
+        <p:nvPicPr>
+          <p:cNvPr id="13" name="图片 12">
+            <a:extLst>
+              <a:ext uri="{FF2B5EF4-FFF2-40B4-BE49-F238E27FC236}">
+                <a16:creationId xmlns:a16="http://schemas.microsoft.com/office/drawing/2014/main" id="{BC09A616-0758-457F-AAE6-72A4699DD5CD}"/>
+              </a:ext>
+            </a:extLst>
+          </p:cNvPr>
+          <p:cNvPicPr>
+            <a:picLocks noChangeAspect="1"/>
+          </p:cNvPicPr>
+          <p:nvPr/>
+        </p:nvPicPr>
+        <p:blipFill>
+          <a:blip r:embed="rId3" cstate="print">
+            <a:extLst>
+              <a:ext uri="{28A0092B-C50C-407E-A947-70E740481C1C}">
+                <a14:useLocalDpi xmlns:a14="http://schemas.microsoft.com/office/drawing/2010/main" val="0"/>
+              </a:ext>
+            </a:extLst>
+          </a:blip>
+          <a:stretch>
+            <a:fillRect/>
+          </a:stretch>
+        </p:blipFill>
+        <p:spPr>
+          <a:xfrm>
+            <a:off x="618361" y="1412172"/>
+            <a:ext cx="10596103" cy="5025600"/>
+          </a:xfrm>
+          <a:prstGeom prst="rect">
+            <a:avLst/>
+          </a:prstGeom>
+        </p:spPr>
+      </p:pic>
+      <p:sp>
+        <p:nvSpPr>
+          <p:cNvPr id="2" name="文本占位符 1">
+            <a:extLst>
+              <a:ext uri="{FF2B5EF4-FFF2-40B4-BE49-F238E27FC236}">
+                <a16:creationId xmlns:a16="http://schemas.microsoft.com/office/drawing/2014/main" id="{9B780FA8-B64E-8F6C-A395-CED1D6F8C26C}"/>
+              </a:ext>
+            </a:extLst>
+          </p:cNvPr>
+          <p:cNvSpPr>
+            <a:spLocks noGrp="1"/>
+          </p:cNvSpPr>
+          <p:nvPr>
+            <p:ph type="body" sz="quarter" idx="12"/>
+          </p:nvPr>
+        </p:nvSpPr>
+        <p:spPr/>
+        <p:txBody>
+          <a:bodyPr wrap="square"/>
+          <a:lstStyle/>
+          <a:p>
+            <a:r>
+              <a:rPr lang="zh-CN" altLang="en-US" sz="2400" dirty="0">
+                <a:solidFill>
+                  <a:schemeClr val="accent1"/>
+                </a:solidFill>
+                <a:latin typeface="Arial" panose="020B0604020202020204" pitchFamily="34" charset="0"/>
+                <a:sym typeface="+mn-ea"/>
+              </a:rPr>
+              <a:t>台架结构仿真结果</a:t>
+            </a:r>
+            <a:r>
+              <a:rPr lang="en-US" altLang="zh-CN" sz="2400" dirty="0">
+                <a:solidFill>
+                  <a:schemeClr val="accent1"/>
+                </a:solidFill>
+                <a:latin typeface="Arial" panose="020B0604020202020204" pitchFamily="34" charset="0"/>
+                <a:sym typeface="+mn-ea"/>
+              </a:rPr>
+              <a:t>2</a:t>
+            </a:r>
+            <a:endParaRPr lang="zh-CN" altLang="en-US" sz="2400" dirty="0">
+              <a:solidFill>
+                <a:schemeClr val="accent1"/>
+              </a:solidFill>
+              <a:latin typeface="Arial" panose="020B0604020202020204" pitchFamily="34" charset="0"/>
+              <a:sym typeface="+mn-ea"/>
+            </a:endParaRPr>
+          </a:p>
+        </p:txBody>
+      </p:sp>
+      <p:sp>
+        <p:nvSpPr>
+          <p:cNvPr id="18" name="文本框 17">
+            <a:extLst>
+              <a:ext uri="{FF2B5EF4-FFF2-40B4-BE49-F238E27FC236}">
+                <a16:creationId xmlns:a16="http://schemas.microsoft.com/office/drawing/2014/main" id="{0F0B04EC-2149-5920-93DE-34AB22B203A5}"/>
+              </a:ext>
+            </a:extLst>
+          </p:cNvPr>
+          <p:cNvSpPr txBox="1"/>
+          <p:nvPr/>
+        </p:nvSpPr>
+        <p:spPr>
+          <a:xfrm>
+            <a:off x="477722" y="957028"/>
+            <a:ext cx="10370805" cy="523220"/>
+          </a:xfrm>
+          <a:prstGeom prst="rect">
+            <a:avLst/>
+          </a:prstGeom>
+          <a:noFill/>
+        </p:spPr>
+        <p:txBody>
+          <a:bodyPr wrap="square">
+            <a:spAutoFit/>
+          </a:bodyPr>
+          <a:lstStyle/>
+          <a:p>
+            <a:pPr marL="285750" indent="-285750">
+              <a:buFont typeface="Wingdings" panose="05000000000000000000" pitchFamily="2" charset="2"/>
+              <a:buChar char="p"/>
+            </a:pPr>
+            <a:r>
+              <a:rPr lang="zh-CN" altLang="en-US" sz="1400" b="1" dirty="0">
+                <a:solidFill>
+                  <a:srgbClr val="152A8C"/>
+                </a:solidFill>
+                <a:latin typeface="Arial" panose="020B0604020202020204" pitchFamily="34" charset="0"/>
+                <a:ea typeface="微软雅黑" panose="020B0503020204020204" pitchFamily="34" charset="-122"/>
+              </a:rPr>
+              <a:t>恒电压</a:t>
+            </a:r>
+            <a:r>
+              <a:rPr lang="en-US" altLang="zh-CN" sz="1400" b="1" dirty="0">
+                <a:solidFill>
+                  <a:srgbClr val="152A8C"/>
+                </a:solidFill>
+                <a:latin typeface="Arial" panose="020B0604020202020204" pitchFamily="34" charset="0"/>
+                <a:ea typeface="微软雅黑" panose="020B0503020204020204" pitchFamily="34" charset="-122"/>
+              </a:rPr>
+              <a:t>EGR</a:t>
+            </a:r>
+            <a:r>
+              <a:rPr lang="zh-CN" altLang="en-US" sz="1400" b="1" dirty="0">
+                <a:solidFill>
+                  <a:srgbClr val="152A8C"/>
+                </a:solidFill>
+                <a:latin typeface="Arial" panose="020B0604020202020204" pitchFamily="34" charset="0"/>
+                <a:ea typeface="微软雅黑" panose="020B0503020204020204" pitchFamily="34" charset="-122"/>
+              </a:rPr>
+              <a:t>扫描（</a:t>
+            </a:r>
+            <a:r>
+              <a:rPr lang="en-US" altLang="zh-CN" sz="1400" b="1" dirty="0">
+                <a:solidFill>
+                  <a:srgbClr val="152A8C"/>
+                </a:solidFill>
+                <a:latin typeface="Arial" panose="020B0604020202020204" pitchFamily="34" charset="0"/>
+                <a:ea typeface="微软雅黑" panose="020B0503020204020204" pitchFamily="34" charset="-122"/>
+              </a:rPr>
+              <a:t>0.8</a:t>
+            </a:r>
+            <a:r>
+              <a:rPr lang="zh-CN" altLang="en-US" sz="1400" b="1" dirty="0">
+                <a:solidFill>
+                  <a:srgbClr val="152A8C"/>
+                </a:solidFill>
+                <a:latin typeface="Arial" panose="020B0604020202020204" pitchFamily="34" charset="0"/>
+                <a:ea typeface="微软雅黑" panose="020B0503020204020204" pitchFamily="34" charset="-122"/>
+              </a:rPr>
+              <a:t>、</a:t>
+            </a:r>
+            <a:r>
+              <a:rPr lang="en-US" altLang="zh-CN" sz="1400" b="1" dirty="0">
+                <a:solidFill>
+                  <a:srgbClr val="152A8C"/>
+                </a:solidFill>
+                <a:latin typeface="Arial" panose="020B0604020202020204" pitchFamily="34" charset="0"/>
+                <a:ea typeface="微软雅黑" panose="020B0503020204020204" pitchFamily="34" charset="-122"/>
+              </a:rPr>
+              <a:t>0.775</a:t>
+            </a:r>
+            <a:r>
+              <a:rPr lang="zh-CN" altLang="en-US" sz="1400" b="1" dirty="0">
+                <a:solidFill>
+                  <a:srgbClr val="152A8C"/>
+                </a:solidFill>
+                <a:latin typeface="Arial" panose="020B0604020202020204" pitchFamily="34" charset="0"/>
+                <a:ea typeface="微软雅黑" panose="020B0503020204020204" pitchFamily="34" charset="-122"/>
+              </a:rPr>
+              <a:t>、</a:t>
+            </a:r>
+            <a:r>
+              <a:rPr lang="en-US" altLang="zh-CN" sz="1400" b="1" dirty="0">
+                <a:solidFill>
+                  <a:srgbClr val="152A8C"/>
+                </a:solidFill>
+                <a:latin typeface="Arial" panose="020B0604020202020204" pitchFamily="34" charset="0"/>
+                <a:ea typeface="微软雅黑" panose="020B0503020204020204" pitchFamily="34" charset="-122"/>
+              </a:rPr>
+              <a:t>0.75 V</a:t>
+            </a:r>
+            <a:r>
+              <a:rPr lang="zh-CN" altLang="en-US" sz="1400" b="1" dirty="0">
+                <a:solidFill>
+                  <a:srgbClr val="152A8C"/>
+                </a:solidFill>
+                <a:latin typeface="Arial" panose="020B0604020202020204" pitchFamily="34" charset="0"/>
+                <a:ea typeface="微软雅黑" panose="020B0503020204020204" pitchFamily="34" charset="-122"/>
+              </a:rPr>
+              <a:t>）：同电压下可输出电流下降</a:t>
+            </a:r>
+          </a:p>
+          <a:p>
+            <a:pPr marL="285750" indent="-285750">
+              <a:buFont typeface="Wingdings" panose="05000000000000000000" pitchFamily="2" charset="2"/>
+              <a:buChar char="p"/>
+            </a:pPr>
+            <a:endParaRPr lang="zh-CN" altLang="en-US" sz="1400" b="1" dirty="0">
+              <a:solidFill>
+                <a:srgbClr val="152A8C"/>
+              </a:solidFill>
+              <a:latin typeface="Arial" panose="020B0604020202020204" pitchFamily="34" charset="0"/>
+              <a:ea typeface="微软雅黑" panose="020B0503020204020204" pitchFamily="34" charset="-122"/>
+            </a:endParaRPr>
+          </a:p>
+        </p:txBody>
+      </p:sp>
+      <p:sp>
+        <p:nvSpPr>
+          <p:cNvPr id="4" name="文本框 3">
+            <a:extLst>
+              <a:ext uri="{FF2B5EF4-FFF2-40B4-BE49-F238E27FC236}">
+                <a16:creationId xmlns:a16="http://schemas.microsoft.com/office/drawing/2014/main" id="{40E25DB3-D903-CB9F-100E-0DF7DD399EBF}"/>
+              </a:ext>
+            </a:extLst>
+          </p:cNvPr>
+          <p:cNvSpPr txBox="1"/>
+          <p:nvPr/>
+        </p:nvSpPr>
+        <p:spPr>
+          <a:xfrm>
+            <a:off x="2207568" y="1896410"/>
+            <a:ext cx="914400" cy="914400"/>
+          </a:xfrm>
+          <a:prstGeom prst="rect">
+            <a:avLst/>
+          </a:prstGeom>
+          <a:noFill/>
+        </p:spPr>
+        <p:txBody>
+          <a:bodyPr wrap="none" lIns="36000" tIns="36000" rIns="36000" bIns="36000" rtlCol="0">
+            <a:noAutofit/>
+          </a:bodyPr>
+          <a:lstStyle/>
+          <a:p>
+            <a:pPr algn="ctr">
+              <a:spcBef>
+                <a:spcPts val="600"/>
+              </a:spcBef>
+            </a:pPr>
+            <a:r>
+              <a:rPr lang="en-US" altLang="zh-CN" sz="1400" dirty="0">
+                <a:solidFill>
+                  <a:schemeClr val="accent4"/>
+                </a:solidFill>
+                <a:latin typeface="+mj-lt"/>
+              </a:rPr>
+              <a:t>1.</a:t>
+            </a:r>
+            <a:r>
+              <a:rPr lang="zh-CN" altLang="en-US" sz="1400" dirty="0">
+                <a:solidFill>
+                  <a:schemeClr val="accent4"/>
+                </a:solidFill>
+                <a:latin typeface="+mj-lt"/>
+              </a:rPr>
+              <a:t>电流</a:t>
+            </a:r>
+          </a:p>
+        </p:txBody>
+      </p:sp>
+      <p:sp>
+        <p:nvSpPr>
+          <p:cNvPr id="5" name="文本框 4">
+            <a:extLst>
+              <a:ext uri="{FF2B5EF4-FFF2-40B4-BE49-F238E27FC236}">
+                <a16:creationId xmlns:a16="http://schemas.microsoft.com/office/drawing/2014/main" id="{EFA68DE5-E093-5A47-6B78-6B5BA9525E7D}"/>
+              </a:ext>
+            </a:extLst>
+          </p:cNvPr>
+          <p:cNvSpPr txBox="1"/>
+          <p:nvPr/>
+        </p:nvSpPr>
+        <p:spPr>
+          <a:xfrm>
+            <a:off x="5638800" y="1896410"/>
+            <a:ext cx="914400" cy="914400"/>
+          </a:xfrm>
+          <a:prstGeom prst="rect">
+            <a:avLst/>
+          </a:prstGeom>
+          <a:noFill/>
+        </p:spPr>
+        <p:txBody>
+          <a:bodyPr wrap="none" lIns="36000" tIns="36000" rIns="36000" bIns="36000" rtlCol="0">
+            <a:noAutofit/>
+          </a:bodyPr>
+          <a:lstStyle/>
+          <a:p>
+            <a:pPr algn="ctr">
+              <a:spcBef>
+                <a:spcPts val="600"/>
+              </a:spcBef>
+            </a:pPr>
+            <a:r>
+              <a:rPr lang="en-US" altLang="zh-CN" sz="1400" dirty="0">
+                <a:solidFill>
+                  <a:schemeClr val="accent4"/>
+                </a:solidFill>
+                <a:latin typeface="+mj-lt"/>
+              </a:rPr>
+              <a:t>2.</a:t>
+            </a:r>
+            <a:r>
+              <a:rPr lang="zh-CN" altLang="en-US" sz="1400" dirty="0">
+                <a:solidFill>
+                  <a:schemeClr val="accent4"/>
+                </a:solidFill>
+                <a:latin typeface="+mj-lt"/>
+              </a:rPr>
+              <a:t>电流密度</a:t>
+            </a:r>
+          </a:p>
+        </p:txBody>
+      </p:sp>
+      <p:sp>
+        <p:nvSpPr>
+          <p:cNvPr id="6" name="文本框 5">
+            <a:extLst>
+              <a:ext uri="{FF2B5EF4-FFF2-40B4-BE49-F238E27FC236}">
+                <a16:creationId xmlns:a16="http://schemas.microsoft.com/office/drawing/2014/main" id="{BD1C3FA0-F967-2796-E133-767B8FE4F4D6}"/>
+              </a:ext>
+            </a:extLst>
+          </p:cNvPr>
+          <p:cNvSpPr txBox="1"/>
+          <p:nvPr/>
+        </p:nvSpPr>
+        <p:spPr>
+          <a:xfrm>
+            <a:off x="9070032" y="1896410"/>
+            <a:ext cx="914400" cy="914400"/>
+          </a:xfrm>
+          <a:prstGeom prst="rect">
+            <a:avLst/>
+          </a:prstGeom>
+          <a:noFill/>
+        </p:spPr>
+        <p:txBody>
+          <a:bodyPr wrap="none" lIns="36000" tIns="36000" rIns="36000" bIns="36000" rtlCol="0">
+            <a:noAutofit/>
+          </a:bodyPr>
+          <a:lstStyle/>
+          <a:p>
+            <a:pPr algn="ctr">
+              <a:spcBef>
+                <a:spcPts val="600"/>
+              </a:spcBef>
+            </a:pPr>
+            <a:r>
+              <a:rPr lang="en-US" altLang="zh-CN" sz="1400" dirty="0">
+                <a:solidFill>
+                  <a:schemeClr val="accent4"/>
+                </a:solidFill>
+                <a:latin typeface="+mj-lt"/>
+              </a:rPr>
+              <a:t>3.</a:t>
+            </a:r>
+            <a:r>
+              <a:rPr lang="zh-CN" altLang="en-US" sz="1400" dirty="0">
+                <a:solidFill>
+                  <a:schemeClr val="accent4"/>
+                </a:solidFill>
+                <a:latin typeface="+mj-lt"/>
+              </a:rPr>
+              <a:t>氢气消耗量</a:t>
+            </a:r>
+          </a:p>
+        </p:txBody>
+      </p:sp>
+      <p:sp>
+        <p:nvSpPr>
+          <p:cNvPr id="7" name="文本框 6">
+            <a:extLst>
+              <a:ext uri="{FF2B5EF4-FFF2-40B4-BE49-F238E27FC236}">
+                <a16:creationId xmlns:a16="http://schemas.microsoft.com/office/drawing/2014/main" id="{73B92A45-CDE4-3EB8-6EAE-1EE4A3A88142}"/>
+              </a:ext>
+            </a:extLst>
+          </p:cNvPr>
+          <p:cNvSpPr txBox="1"/>
+          <p:nvPr/>
+        </p:nvSpPr>
+        <p:spPr>
+          <a:xfrm>
+            <a:off x="2156139" y="4313220"/>
+            <a:ext cx="914400" cy="914400"/>
+          </a:xfrm>
+          <a:prstGeom prst="rect">
+            <a:avLst/>
+          </a:prstGeom>
+          <a:noFill/>
+        </p:spPr>
+        <p:txBody>
+          <a:bodyPr wrap="none" lIns="36000" tIns="36000" rIns="36000" bIns="36000" rtlCol="0">
+            <a:noAutofit/>
+          </a:bodyPr>
+          <a:lstStyle/>
+          <a:p>
+            <a:pPr algn="ctr">
+              <a:spcBef>
+                <a:spcPts val="600"/>
+              </a:spcBef>
+            </a:pPr>
+            <a:r>
+              <a:rPr lang="en-US" altLang="zh-CN" sz="1400" dirty="0">
+                <a:solidFill>
+                  <a:schemeClr val="accent4"/>
+                </a:solidFill>
+                <a:latin typeface="+mj-lt"/>
+              </a:rPr>
+              <a:t>4.</a:t>
+            </a:r>
+            <a:r>
+              <a:rPr lang="zh-CN" altLang="en-US" sz="1400" dirty="0">
+                <a:solidFill>
+                  <a:schemeClr val="accent4"/>
+                </a:solidFill>
+                <a:latin typeface="+mj-lt"/>
+              </a:rPr>
+              <a:t>电堆功率</a:t>
+            </a:r>
+          </a:p>
+        </p:txBody>
+      </p:sp>
+      <p:sp>
+        <p:nvSpPr>
+          <p:cNvPr id="8" name="文本框 7">
+            <a:extLst>
+              <a:ext uri="{FF2B5EF4-FFF2-40B4-BE49-F238E27FC236}">
+                <a16:creationId xmlns:a16="http://schemas.microsoft.com/office/drawing/2014/main" id="{AB32365D-1948-5DF4-63F6-6107DDB90B39}"/>
+              </a:ext>
+            </a:extLst>
+          </p:cNvPr>
+          <p:cNvSpPr txBox="1"/>
+          <p:nvPr/>
+        </p:nvSpPr>
+        <p:spPr>
+          <a:xfrm>
+            <a:off x="5638800" y="4313220"/>
+            <a:ext cx="914400" cy="914400"/>
+          </a:xfrm>
+          <a:prstGeom prst="rect">
+            <a:avLst/>
+          </a:prstGeom>
+          <a:noFill/>
+        </p:spPr>
+        <p:txBody>
+          <a:bodyPr wrap="none" lIns="36000" tIns="36000" rIns="36000" bIns="36000" rtlCol="0">
+            <a:noAutofit/>
+          </a:bodyPr>
+          <a:lstStyle/>
+          <a:p>
+            <a:pPr algn="ctr">
+              <a:spcBef>
+                <a:spcPts val="600"/>
+              </a:spcBef>
+            </a:pPr>
+            <a:r>
+              <a:rPr lang="en-US" altLang="zh-CN" sz="1400" dirty="0">
+                <a:solidFill>
+                  <a:schemeClr val="accent4"/>
+                </a:solidFill>
+                <a:latin typeface="+mj-lt"/>
+              </a:rPr>
+              <a:t>5.</a:t>
+            </a:r>
+            <a:r>
+              <a:rPr lang="zh-CN" altLang="en-US" sz="1400" dirty="0">
+                <a:solidFill>
+                  <a:schemeClr val="accent4"/>
+                </a:solidFill>
+                <a:latin typeface="+mj-lt"/>
+              </a:rPr>
+              <a:t>氧计量比</a:t>
+            </a:r>
+          </a:p>
+        </p:txBody>
+      </p:sp>
+      <p:sp>
+        <p:nvSpPr>
+          <p:cNvPr id="9" name="文本框 8">
+            <a:extLst>
+              <a:ext uri="{FF2B5EF4-FFF2-40B4-BE49-F238E27FC236}">
+                <a16:creationId xmlns:a16="http://schemas.microsoft.com/office/drawing/2014/main" id="{810D1690-90ED-D6EC-C0C1-BA957259E94C}"/>
+              </a:ext>
+            </a:extLst>
+          </p:cNvPr>
+          <p:cNvSpPr txBox="1"/>
+          <p:nvPr/>
+        </p:nvSpPr>
+        <p:spPr>
+          <a:xfrm>
+            <a:off x="9070032" y="4313220"/>
+            <a:ext cx="914400" cy="914400"/>
+          </a:xfrm>
+          <a:prstGeom prst="rect">
+            <a:avLst/>
+          </a:prstGeom>
+          <a:noFill/>
+        </p:spPr>
+        <p:txBody>
+          <a:bodyPr wrap="none" lIns="36000" tIns="36000" rIns="36000" bIns="36000" rtlCol="0">
+            <a:noAutofit/>
+          </a:bodyPr>
+          <a:lstStyle/>
+          <a:p>
+            <a:pPr algn="ctr">
+              <a:spcBef>
+                <a:spcPts val="600"/>
+              </a:spcBef>
+            </a:pPr>
+            <a:r>
+              <a:rPr lang="en-US" altLang="zh-CN" sz="1400" dirty="0">
+                <a:solidFill>
+                  <a:schemeClr val="accent4"/>
+                </a:solidFill>
+                <a:latin typeface="+mj-lt"/>
+              </a:rPr>
+              <a:t>6.</a:t>
+            </a:r>
+            <a:r>
+              <a:rPr lang="zh-CN" altLang="en-US" sz="1400" dirty="0">
+                <a:solidFill>
+                  <a:schemeClr val="accent4"/>
+                </a:solidFill>
+                <a:latin typeface="+mj-lt"/>
+              </a:rPr>
+              <a:t>阴极入口含湿量</a:t>
+            </a:r>
+          </a:p>
+        </p:txBody>
+      </p:sp>
+    </p:spTree>
+    <p:extLst>
+      <p:ext uri="{BB962C8B-B14F-4D97-AF65-F5344CB8AC3E}">
+        <p14:creationId xmlns:p14="http://schemas.microsoft.com/office/powerpoint/2010/main" val="4161143545"/>
+      </p:ext>
+    </p:extLst>
+  </p:cSld>
+  <p:clrMapOvr>
+    <a:masterClrMapping/>
+  </p:clrMapOvr>
+</p:sld>
+</file>
+
+<file path=ppt/slides/slide8.xml><?xml version="1.0" encoding="utf-8"?>
+<p:sld xmlns:a="http://schemas.openxmlformats.org/drawingml/2006/main" xmlns:r="http://schemas.openxmlformats.org/officeDocument/2006/relationships" xmlns:p="http://schemas.openxmlformats.org/presentationml/2006/main">
+  <p:cSld>
+    <p:spTree>
+      <p:nvGrpSpPr>
+        <p:cNvPr id="1" name="">
+          <a:extLst>
+            <a:ext uri="{FF2B5EF4-FFF2-40B4-BE49-F238E27FC236}">
+              <a16:creationId xmlns:a16="http://schemas.microsoft.com/office/drawing/2014/main" id="{618A3FED-3D29-C799-A104-DEEBD4213FA3}"/>
+            </a:ext>
+          </a:extLst>
+        </p:cNvPr>
+        <p:cNvGrpSpPr/>
+        <p:nvPr/>
+      </p:nvGrpSpPr>
+      <p:grpSpPr>
+        <a:xfrm>
+          <a:off x="0" y="0"/>
+          <a:ext cx="0" cy="0"/>
+          <a:chOff x="0" y="0"/>
+          <a:chExt cx="0" cy="0"/>
+        </a:xfrm>
+      </p:grpSpPr>
+      <p:pic>
+        <p:nvPicPr>
+          <p:cNvPr id="13" name="图片 12">
+            <a:extLst>
+              <a:ext uri="{FF2B5EF4-FFF2-40B4-BE49-F238E27FC236}">
+                <a16:creationId xmlns:a16="http://schemas.microsoft.com/office/drawing/2014/main" id="{F80A2AC0-D4D4-E438-D831-238618DDA00B}"/>
+              </a:ext>
+            </a:extLst>
+          </p:cNvPr>
+          <p:cNvPicPr>
+            <a:picLocks noChangeAspect="1"/>
+          </p:cNvPicPr>
+          <p:nvPr/>
+        </p:nvPicPr>
+        <p:blipFill>
+          <a:blip r:embed="rId3" cstate="print">
+            <a:extLst>
+              <a:ext uri="{28A0092B-C50C-407E-A947-70E740481C1C}">
+                <a14:useLocalDpi xmlns:a14="http://schemas.microsoft.com/office/drawing/2010/main" val="0"/>
+              </a:ext>
+            </a:extLst>
+          </a:blip>
+          <a:stretch>
+            <a:fillRect/>
+          </a:stretch>
+        </p:blipFill>
+        <p:spPr>
+          <a:xfrm>
+            <a:off x="733632" y="1399174"/>
+            <a:ext cx="10485640" cy="5025600"/>
+          </a:xfrm>
+          <a:prstGeom prst="rect">
+            <a:avLst/>
+          </a:prstGeom>
+        </p:spPr>
+      </p:pic>
+      <p:sp>
+        <p:nvSpPr>
+          <p:cNvPr id="2" name="文本占位符 1">
+            <a:extLst>
+              <a:ext uri="{FF2B5EF4-FFF2-40B4-BE49-F238E27FC236}">
+                <a16:creationId xmlns:a16="http://schemas.microsoft.com/office/drawing/2014/main" id="{1F367618-DBD6-A022-4F3A-357F148AD416}"/>
+              </a:ext>
+            </a:extLst>
+          </p:cNvPr>
+          <p:cNvSpPr>
+            <a:spLocks noGrp="1"/>
+          </p:cNvSpPr>
+          <p:nvPr>
+            <p:ph type="body" sz="quarter" idx="12"/>
+          </p:nvPr>
+        </p:nvSpPr>
+        <p:spPr/>
+        <p:txBody>
+          <a:bodyPr wrap="square"/>
+          <a:lstStyle/>
+          <a:p>
+            <a:r>
+              <a:rPr lang="zh-CN" altLang="en-US" sz="2400" dirty="0">
+                <a:solidFill>
+                  <a:schemeClr val="accent1"/>
+                </a:solidFill>
+                <a:latin typeface="Arial" panose="020B0604020202020204" pitchFamily="34" charset="0"/>
+                <a:sym typeface="+mn-ea"/>
+              </a:rPr>
+              <a:t>台架结构仿真结果</a:t>
+            </a:r>
+            <a:r>
+              <a:rPr lang="en-US" altLang="zh-CN" sz="2400" dirty="0">
+                <a:solidFill>
+                  <a:schemeClr val="accent1"/>
+                </a:solidFill>
+                <a:latin typeface="Arial" panose="020B0604020202020204" pitchFamily="34" charset="0"/>
+                <a:sym typeface="+mn-ea"/>
+              </a:rPr>
+              <a:t>1</a:t>
+            </a:r>
+            <a:endParaRPr lang="zh-CN" altLang="en-US" sz="2400" dirty="0">
+              <a:solidFill>
+                <a:schemeClr val="accent1"/>
+              </a:solidFill>
+              <a:latin typeface="Arial" panose="020B0604020202020204" pitchFamily="34" charset="0"/>
+              <a:sym typeface="+mn-ea"/>
+            </a:endParaRPr>
+          </a:p>
+        </p:txBody>
+      </p:sp>
+      <p:sp>
+        <p:nvSpPr>
+          <p:cNvPr id="18" name="文本框 17">
+            <a:extLst>
+              <a:ext uri="{FF2B5EF4-FFF2-40B4-BE49-F238E27FC236}">
+                <a16:creationId xmlns:a16="http://schemas.microsoft.com/office/drawing/2014/main" id="{CD576464-E724-F4B9-E864-F1379C33FA32}"/>
+              </a:ext>
+            </a:extLst>
+          </p:cNvPr>
+          <p:cNvSpPr txBox="1"/>
+          <p:nvPr/>
+        </p:nvSpPr>
+        <p:spPr>
+          <a:xfrm>
+            <a:off x="477723" y="957028"/>
+            <a:ext cx="6480720" cy="307777"/>
+          </a:xfrm>
+          <a:prstGeom prst="rect">
+            <a:avLst/>
+          </a:prstGeom>
+          <a:noFill/>
+        </p:spPr>
+        <p:txBody>
+          <a:bodyPr wrap="square">
+            <a:spAutoFit/>
+          </a:bodyPr>
+          <a:lstStyle/>
+          <a:p>
+            <a:pPr marL="285750" indent="-285750">
+              <a:buFont typeface="Wingdings" panose="05000000000000000000" pitchFamily="2" charset="2"/>
+              <a:buChar char="p"/>
+            </a:pPr>
+            <a:r>
+              <a:rPr lang="zh-CN" altLang="en-US" sz="1400" b="1" dirty="0">
+                <a:solidFill>
+                  <a:srgbClr val="152A8C"/>
+                </a:solidFill>
+                <a:latin typeface="Arial" panose="020B0604020202020204" pitchFamily="34" charset="0"/>
+                <a:ea typeface="微软雅黑" panose="020B0503020204020204" pitchFamily="34" charset="-122"/>
+              </a:rPr>
+              <a:t>恒氧分压</a:t>
+            </a:r>
+            <a:r>
+              <a:rPr lang="en-US" altLang="zh-CN" sz="1400" b="1" dirty="0">
+                <a:solidFill>
+                  <a:srgbClr val="152A8C"/>
+                </a:solidFill>
+                <a:latin typeface="Arial" panose="020B0604020202020204" pitchFamily="34" charset="0"/>
+                <a:ea typeface="微软雅黑" panose="020B0503020204020204" pitchFamily="34" charset="-122"/>
+              </a:rPr>
+              <a:t>EGR</a:t>
+            </a:r>
+            <a:r>
+              <a:rPr lang="zh-CN" altLang="en-US" sz="1400" b="1" dirty="0">
+                <a:solidFill>
+                  <a:srgbClr val="152A8C"/>
+                </a:solidFill>
+                <a:latin typeface="Arial" panose="020B0604020202020204" pitchFamily="34" charset="0"/>
+                <a:ea typeface="微软雅黑" panose="020B0503020204020204" pitchFamily="34" charset="-122"/>
+              </a:rPr>
+              <a:t>扫描（</a:t>
+            </a:r>
+            <a:r>
+              <a:rPr lang="en-US" altLang="zh-CN" sz="1400" b="1" dirty="0">
+                <a:solidFill>
+                  <a:srgbClr val="152A8C"/>
+                </a:solidFill>
+                <a:latin typeface="Arial" panose="020B0604020202020204" pitchFamily="34" charset="0"/>
+                <a:ea typeface="微软雅黑" panose="020B0503020204020204" pitchFamily="34" charset="-122"/>
+              </a:rPr>
+              <a:t>0-0.25EGR</a:t>
+            </a:r>
+            <a:r>
+              <a:rPr lang="zh-CN" altLang="en-US" sz="1400" b="1" dirty="0">
+                <a:solidFill>
+                  <a:srgbClr val="152A8C"/>
+                </a:solidFill>
+                <a:latin typeface="Arial" panose="020B0604020202020204" pitchFamily="34" charset="0"/>
+                <a:ea typeface="微软雅黑" panose="020B0503020204020204" pitchFamily="34" charset="-122"/>
+              </a:rPr>
+              <a:t> </a:t>
+            </a:r>
+            <a:r>
+              <a:rPr lang="en-US" altLang="zh-CN" sz="1400" b="1" dirty="0">
+                <a:solidFill>
+                  <a:srgbClr val="152A8C"/>
+                </a:solidFill>
+                <a:latin typeface="Arial" panose="020B0604020202020204" pitchFamily="34" charset="0"/>
+                <a:ea typeface="微软雅黑" panose="020B0503020204020204" pitchFamily="34" charset="-122"/>
+              </a:rPr>
+              <a:t>0.1 A/cm</a:t>
+            </a:r>
+            <a:r>
+              <a:rPr lang="en-US" altLang="zh-CN" sz="1400" b="1" baseline="30000" dirty="0">
+                <a:solidFill>
+                  <a:srgbClr val="152A8C"/>
+                </a:solidFill>
+                <a:latin typeface="Arial" panose="020B0604020202020204" pitchFamily="34" charset="0"/>
+                <a:ea typeface="微软雅黑" panose="020B0503020204020204" pitchFamily="34" charset="-122"/>
+              </a:rPr>
+              <a:t>2 </a:t>
+            </a:r>
+            <a:r>
+              <a:rPr lang="zh-CN" altLang="en-US" sz="1400" b="1" dirty="0">
+                <a:solidFill>
+                  <a:srgbClr val="152A8C"/>
+                </a:solidFill>
+                <a:latin typeface="Arial" panose="020B0604020202020204" pitchFamily="34" charset="0"/>
+                <a:ea typeface="微软雅黑" panose="020B0503020204020204" pitchFamily="34" charset="-122"/>
+              </a:rPr>
+              <a:t>）：维持氧分压需要更高供气</a:t>
+            </a:r>
+          </a:p>
+        </p:txBody>
+      </p:sp>
+      <p:sp>
+        <p:nvSpPr>
+          <p:cNvPr id="4" name="文本框 3">
+            <a:extLst>
+              <a:ext uri="{FF2B5EF4-FFF2-40B4-BE49-F238E27FC236}">
+                <a16:creationId xmlns:a16="http://schemas.microsoft.com/office/drawing/2014/main" id="{0C63A03B-19A3-A1E1-8AB0-AD1E7B7539D9}"/>
+              </a:ext>
+            </a:extLst>
+          </p:cNvPr>
+          <p:cNvSpPr txBox="1"/>
+          <p:nvPr/>
+        </p:nvSpPr>
+        <p:spPr>
+          <a:xfrm>
             <a:off x="2207568" y="1947996"/>
             <a:ext cx="914400" cy="914400"/>
           </a:xfrm>
@@ -8086,7 +10946,7 @@
                 </a:solidFill>
                 <a:latin typeface="+mj-lt"/>
               </a:rPr>
-              <a:t>电压</a:t>
+              <a:t>氧分压</a:t>
             </a:r>
           </a:p>
         </p:txBody>
@@ -8096,7 +10956,7 @@
           <p:cNvPr id="5" name="文本框 4">
             <a:extLst>
               <a:ext uri="{FF2B5EF4-FFF2-40B4-BE49-F238E27FC236}">
-                <a16:creationId xmlns:a16="http://schemas.microsoft.com/office/drawing/2014/main" id="{B5260BA2-6F83-E971-ED75-4F083A21F2EA}"/>
+                <a16:creationId xmlns:a16="http://schemas.microsoft.com/office/drawing/2014/main" id="{7AA329D8-80BD-F1D0-CE83-E8AACC017CFA}"/>
               </a:ext>
             </a:extLst>
           </p:cNvPr>
@@ -8140,7 +11000,7 @@
                 </a:solidFill>
                 <a:latin typeface="+mj-lt"/>
               </a:rPr>
-              <a:t>阴极入口氧分压</a:t>
+              <a:t>电压</a:t>
             </a:r>
           </a:p>
         </p:txBody>
@@ -8150,7 +11010,7 @@
           <p:cNvPr id="6" name="文本框 5">
             <a:extLst>
               <a:ext uri="{FF2B5EF4-FFF2-40B4-BE49-F238E27FC236}">
-                <a16:creationId xmlns:a16="http://schemas.microsoft.com/office/drawing/2014/main" id="{667208A5-C5B5-2A88-463F-5EDE9B1401D5}"/>
+                <a16:creationId xmlns:a16="http://schemas.microsoft.com/office/drawing/2014/main" id="{35C93E06-5A28-A861-1E66-B599E50D0888}"/>
               </a:ext>
             </a:extLst>
           </p:cNvPr>
@@ -8194,7 +11054,7 @@
                 </a:solidFill>
                 <a:latin typeface="+mj-lt"/>
               </a:rPr>
-              <a:t>氧计量比</a:t>
+              <a:t>计量比</a:t>
             </a:r>
           </a:p>
         </p:txBody>
@@ -8204,7 +11064,7 @@
           <p:cNvPr id="7" name="文本框 6">
             <a:extLst>
               <a:ext uri="{FF2B5EF4-FFF2-40B4-BE49-F238E27FC236}">
-                <a16:creationId xmlns:a16="http://schemas.microsoft.com/office/drawing/2014/main" id="{E1A6F071-81AF-A59A-1FAD-CF3C6F69FF4B}"/>
+                <a16:creationId xmlns:a16="http://schemas.microsoft.com/office/drawing/2014/main" id="{00EC7424-5D78-9061-72E2-B7E831F24426}"/>
               </a:ext>
             </a:extLst>
           </p:cNvPr>
@@ -8258,7 +11118,7 @@
           <p:cNvPr id="8" name="文本框 7">
             <a:extLst>
               <a:ext uri="{FF2B5EF4-FFF2-40B4-BE49-F238E27FC236}">
-                <a16:creationId xmlns:a16="http://schemas.microsoft.com/office/drawing/2014/main" id="{9EAF24CA-7E6B-A510-956F-238C2B2C2A7C}"/>
+                <a16:creationId xmlns:a16="http://schemas.microsoft.com/office/drawing/2014/main" id="{D31D15EC-1BCA-7239-226E-7FB3064BEDE7}"/>
               </a:ext>
             </a:extLst>
           </p:cNvPr>
@@ -8302,7 +11162,7 @@
                 </a:solidFill>
                 <a:latin typeface="+mj-lt"/>
               </a:rPr>
-              <a:t>阴极入口水蒸气分压</a:t>
+              <a:t>阴极入口流量</a:t>
             </a:r>
           </a:p>
         </p:txBody>
@@ -8312,7 +11172,7 @@
           <p:cNvPr id="9" name="文本框 8">
             <a:extLst>
               <a:ext uri="{FF2B5EF4-FFF2-40B4-BE49-F238E27FC236}">
-                <a16:creationId xmlns:a16="http://schemas.microsoft.com/office/drawing/2014/main" id="{BA1994F6-AE87-3172-23C9-A8309291CDA9}"/>
+                <a16:creationId xmlns:a16="http://schemas.microsoft.com/office/drawing/2014/main" id="{CFBC6F01-E390-81AF-3C7C-E42A54593B51}"/>
               </a:ext>
             </a:extLst>
           </p:cNvPr>
@@ -8356,7 +11216,7 @@
                 </a:solidFill>
                 <a:latin typeface="+mj-lt"/>
               </a:rPr>
-              <a:t>温度</a:t>
+              <a:t>入堆压力</a:t>
             </a:r>
           </a:p>
         </p:txBody>
@@ -8364,7 +11224,7 @@
     </p:spTree>
     <p:extLst>
       <p:ext uri="{BB962C8B-B14F-4D97-AF65-F5344CB8AC3E}">
-        <p14:creationId xmlns:p14="http://schemas.microsoft.com/office/powerpoint/2010/main" val="914471329"/>
+        <p14:creationId xmlns:p14="http://schemas.microsoft.com/office/powerpoint/2010/main" val="211921244"/>
       </p:ext>
     </p:extLst>
   </p:cSld>

</xml_diff>